<commit_message>
update Get Started page
</commit_message>
<xml_diff>
--- a/vignettes/images/images.pptx
+++ b/vignettes/images/images.pptx
@@ -5,7 +5,9 @@
     <p:sldMasterId id="2147483648" r:id="rId1"/>
   </p:sldMasterIdLst>
   <p:sldIdLst>
-    <p:sldId id="256" r:id="rId2"/>
+    <p:sldId id="257" r:id="rId2"/>
+    <p:sldId id="258" r:id="rId3"/>
+    <p:sldId id="259" r:id="rId4"/>
   </p:sldIdLst>
   <p:sldSz cx="12192000" cy="6858000"/>
   <p:notesSz cx="6858000" cy="9144000"/>
@@ -104,6 +106,11 @@
       </a:defRPr>
     </a:lvl9pPr>
   </p:defaultTextStyle>
+  <p:extLst>
+    <p:ext uri="{EFAFB233-063F-42B5-8137-9DF3F51BA10A}">
+      <p15:sldGuideLst xmlns:p15="http://schemas.microsoft.com/office/powerpoint/2012/main"/>
+    </p:ext>
+  </p:extLst>
 </p:presentation>
 </file>
 
@@ -256,9 +263,9 @@
           <a:p>
             <a:fld id="{0C105CC3-179F-4A2D-9012-371B48952F93}" type="datetimeFigureOut">
               <a:rPr lang="de-DE" smtClean="0"/>
-              <a:t>17.02.2026</a:t>
+              <a:t>19.02.2026</a:t>
             </a:fld>
-            <a:endParaRPr lang="de-DE"/>
+            <a:endParaRPr lang="de-DE" dirty="0"/>
           </a:p>
         </p:txBody>
       </p:sp>
@@ -283,7 +290,7 @@
           <a:bodyPr/>
           <a:lstStyle/>
           <a:p>
-            <a:endParaRPr lang="de-DE"/>
+            <a:endParaRPr lang="de-DE" dirty="0"/>
           </a:p>
         </p:txBody>
       </p:sp>
@@ -312,7 +319,7 @@
               <a:rPr lang="de-DE" smtClean="0"/>
               <a:t>‹#›</a:t>
             </a:fld>
-            <a:endParaRPr lang="de-DE"/>
+            <a:endParaRPr lang="de-DE" dirty="0"/>
           </a:p>
         </p:txBody>
       </p:sp>
@@ -456,9 +463,9 @@
           <a:p>
             <a:fld id="{0C105CC3-179F-4A2D-9012-371B48952F93}" type="datetimeFigureOut">
               <a:rPr lang="de-DE" smtClean="0"/>
-              <a:t>17.02.2026</a:t>
+              <a:t>19.02.2026</a:t>
             </a:fld>
-            <a:endParaRPr lang="de-DE"/>
+            <a:endParaRPr lang="de-DE" dirty="0"/>
           </a:p>
         </p:txBody>
       </p:sp>
@@ -483,7 +490,7 @@
           <a:bodyPr/>
           <a:lstStyle/>
           <a:p>
-            <a:endParaRPr lang="de-DE"/>
+            <a:endParaRPr lang="de-DE" dirty="0"/>
           </a:p>
         </p:txBody>
       </p:sp>
@@ -512,7 +519,7 @@
               <a:rPr lang="de-DE" smtClean="0"/>
               <a:t>‹#›</a:t>
             </a:fld>
-            <a:endParaRPr lang="de-DE"/>
+            <a:endParaRPr lang="de-DE" dirty="0"/>
           </a:p>
         </p:txBody>
       </p:sp>
@@ -666,9 +673,9 @@
           <a:p>
             <a:fld id="{0C105CC3-179F-4A2D-9012-371B48952F93}" type="datetimeFigureOut">
               <a:rPr lang="de-DE" smtClean="0"/>
-              <a:t>17.02.2026</a:t>
+              <a:t>19.02.2026</a:t>
             </a:fld>
-            <a:endParaRPr lang="de-DE"/>
+            <a:endParaRPr lang="de-DE" dirty="0"/>
           </a:p>
         </p:txBody>
       </p:sp>
@@ -693,7 +700,7 @@
           <a:bodyPr/>
           <a:lstStyle/>
           <a:p>
-            <a:endParaRPr lang="de-DE"/>
+            <a:endParaRPr lang="de-DE" dirty="0"/>
           </a:p>
         </p:txBody>
       </p:sp>
@@ -722,7 +729,7 @@
               <a:rPr lang="de-DE" smtClean="0"/>
               <a:t>‹#›</a:t>
             </a:fld>
-            <a:endParaRPr lang="de-DE"/>
+            <a:endParaRPr lang="de-DE" dirty="0"/>
           </a:p>
         </p:txBody>
       </p:sp>
@@ -866,9 +873,9 @@
           <a:p>
             <a:fld id="{0C105CC3-179F-4A2D-9012-371B48952F93}" type="datetimeFigureOut">
               <a:rPr lang="de-DE" smtClean="0"/>
-              <a:t>17.02.2026</a:t>
+              <a:t>19.02.2026</a:t>
             </a:fld>
-            <a:endParaRPr lang="de-DE"/>
+            <a:endParaRPr lang="de-DE" dirty="0"/>
           </a:p>
         </p:txBody>
       </p:sp>
@@ -893,7 +900,7 @@
           <a:bodyPr/>
           <a:lstStyle/>
           <a:p>
-            <a:endParaRPr lang="de-DE"/>
+            <a:endParaRPr lang="de-DE" dirty="0"/>
           </a:p>
         </p:txBody>
       </p:sp>
@@ -922,7 +929,7 @@
               <a:rPr lang="de-DE" smtClean="0"/>
               <a:t>‹#›</a:t>
             </a:fld>
-            <a:endParaRPr lang="de-DE"/>
+            <a:endParaRPr lang="de-DE" dirty="0"/>
           </a:p>
         </p:txBody>
       </p:sp>
@@ -1142,9 +1149,9 @@
           <a:p>
             <a:fld id="{0C105CC3-179F-4A2D-9012-371B48952F93}" type="datetimeFigureOut">
               <a:rPr lang="de-DE" smtClean="0"/>
-              <a:t>17.02.2026</a:t>
+              <a:t>19.02.2026</a:t>
             </a:fld>
-            <a:endParaRPr lang="de-DE"/>
+            <a:endParaRPr lang="de-DE" dirty="0"/>
           </a:p>
         </p:txBody>
       </p:sp>
@@ -1169,7 +1176,7 @@
           <a:bodyPr/>
           <a:lstStyle/>
           <a:p>
-            <a:endParaRPr lang="de-DE"/>
+            <a:endParaRPr lang="de-DE" dirty="0"/>
           </a:p>
         </p:txBody>
       </p:sp>
@@ -1198,7 +1205,7 @@
               <a:rPr lang="de-DE" smtClean="0"/>
               <a:t>‹#›</a:t>
             </a:fld>
-            <a:endParaRPr lang="de-DE"/>
+            <a:endParaRPr lang="de-DE" dirty="0"/>
           </a:p>
         </p:txBody>
       </p:sp>
@@ -1410,9 +1417,9 @@
           <a:p>
             <a:fld id="{0C105CC3-179F-4A2D-9012-371B48952F93}" type="datetimeFigureOut">
               <a:rPr lang="de-DE" smtClean="0"/>
-              <a:t>17.02.2026</a:t>
+              <a:t>19.02.2026</a:t>
             </a:fld>
-            <a:endParaRPr lang="de-DE"/>
+            <a:endParaRPr lang="de-DE" dirty="0"/>
           </a:p>
         </p:txBody>
       </p:sp>
@@ -1437,7 +1444,7 @@
           <a:bodyPr/>
           <a:lstStyle/>
           <a:p>
-            <a:endParaRPr lang="de-DE"/>
+            <a:endParaRPr lang="de-DE" dirty="0"/>
           </a:p>
         </p:txBody>
       </p:sp>
@@ -1466,7 +1473,7 @@
               <a:rPr lang="de-DE" smtClean="0"/>
               <a:t>‹#›</a:t>
             </a:fld>
-            <a:endParaRPr lang="de-DE"/>
+            <a:endParaRPr lang="de-DE" dirty="0"/>
           </a:p>
         </p:txBody>
       </p:sp>
@@ -1825,9 +1832,9 @@
           <a:p>
             <a:fld id="{0C105CC3-179F-4A2D-9012-371B48952F93}" type="datetimeFigureOut">
               <a:rPr lang="de-DE" smtClean="0"/>
-              <a:t>17.02.2026</a:t>
+              <a:t>19.02.2026</a:t>
             </a:fld>
-            <a:endParaRPr lang="de-DE"/>
+            <a:endParaRPr lang="de-DE" dirty="0"/>
           </a:p>
         </p:txBody>
       </p:sp>
@@ -1852,7 +1859,7 @@
           <a:bodyPr/>
           <a:lstStyle/>
           <a:p>
-            <a:endParaRPr lang="de-DE"/>
+            <a:endParaRPr lang="de-DE" dirty="0"/>
           </a:p>
         </p:txBody>
       </p:sp>
@@ -1881,7 +1888,7 @@
               <a:rPr lang="de-DE" smtClean="0"/>
               <a:t>‹#›</a:t>
             </a:fld>
-            <a:endParaRPr lang="de-DE"/>
+            <a:endParaRPr lang="de-DE" dirty="0"/>
           </a:p>
         </p:txBody>
       </p:sp>
@@ -1967,9 +1974,9 @@
           <a:p>
             <a:fld id="{0C105CC3-179F-4A2D-9012-371B48952F93}" type="datetimeFigureOut">
               <a:rPr lang="de-DE" smtClean="0"/>
-              <a:t>17.02.2026</a:t>
+              <a:t>19.02.2026</a:t>
             </a:fld>
-            <a:endParaRPr lang="de-DE"/>
+            <a:endParaRPr lang="de-DE" dirty="0"/>
           </a:p>
         </p:txBody>
       </p:sp>
@@ -1994,7 +2001,7 @@
           <a:bodyPr/>
           <a:lstStyle/>
           <a:p>
-            <a:endParaRPr lang="de-DE"/>
+            <a:endParaRPr lang="de-DE" dirty="0"/>
           </a:p>
         </p:txBody>
       </p:sp>
@@ -2023,7 +2030,7 @@
               <a:rPr lang="de-DE" smtClean="0"/>
               <a:t>‹#›</a:t>
             </a:fld>
-            <a:endParaRPr lang="de-DE"/>
+            <a:endParaRPr lang="de-DE" dirty="0"/>
           </a:p>
         </p:txBody>
       </p:sp>
@@ -2080,9 +2087,9 @@
           <a:p>
             <a:fld id="{0C105CC3-179F-4A2D-9012-371B48952F93}" type="datetimeFigureOut">
               <a:rPr lang="de-DE" smtClean="0"/>
-              <a:t>17.02.2026</a:t>
+              <a:t>19.02.2026</a:t>
             </a:fld>
-            <a:endParaRPr lang="de-DE"/>
+            <a:endParaRPr lang="de-DE" dirty="0"/>
           </a:p>
         </p:txBody>
       </p:sp>
@@ -2107,7 +2114,7 @@
           <a:bodyPr/>
           <a:lstStyle/>
           <a:p>
-            <a:endParaRPr lang="de-DE"/>
+            <a:endParaRPr lang="de-DE" dirty="0"/>
           </a:p>
         </p:txBody>
       </p:sp>
@@ -2136,7 +2143,7 @@
               <a:rPr lang="de-DE" smtClean="0"/>
               <a:t>‹#›</a:t>
             </a:fld>
-            <a:endParaRPr lang="de-DE"/>
+            <a:endParaRPr lang="de-DE" dirty="0"/>
           </a:p>
         </p:txBody>
       </p:sp>
@@ -2393,9 +2400,9 @@
           <a:p>
             <a:fld id="{0C105CC3-179F-4A2D-9012-371B48952F93}" type="datetimeFigureOut">
               <a:rPr lang="de-DE" smtClean="0"/>
-              <a:t>17.02.2026</a:t>
+              <a:t>19.02.2026</a:t>
             </a:fld>
-            <a:endParaRPr lang="de-DE"/>
+            <a:endParaRPr lang="de-DE" dirty="0"/>
           </a:p>
         </p:txBody>
       </p:sp>
@@ -2420,7 +2427,7 @@
           <a:bodyPr/>
           <a:lstStyle/>
           <a:p>
-            <a:endParaRPr lang="de-DE"/>
+            <a:endParaRPr lang="de-DE" dirty="0"/>
           </a:p>
         </p:txBody>
       </p:sp>
@@ -2449,7 +2456,7 @@
               <a:rPr lang="de-DE" smtClean="0"/>
               <a:t>‹#›</a:t>
             </a:fld>
-            <a:endParaRPr lang="de-DE"/>
+            <a:endParaRPr lang="de-DE" dirty="0"/>
           </a:p>
         </p:txBody>
       </p:sp>
@@ -2584,7 +2591,7 @@
             </a:lvl9pPr>
           </a:lstStyle>
           <a:p>
-            <a:endParaRPr lang="de-DE"/>
+            <a:endParaRPr lang="de-DE" dirty="0"/>
           </a:p>
         </p:txBody>
       </p:sp>
@@ -2682,9 +2689,9 @@
           <a:p>
             <a:fld id="{0C105CC3-179F-4A2D-9012-371B48952F93}" type="datetimeFigureOut">
               <a:rPr lang="de-DE" smtClean="0"/>
-              <a:t>17.02.2026</a:t>
+              <a:t>19.02.2026</a:t>
             </a:fld>
-            <a:endParaRPr lang="de-DE"/>
+            <a:endParaRPr lang="de-DE" dirty="0"/>
           </a:p>
         </p:txBody>
       </p:sp>
@@ -2709,7 +2716,7 @@
           <a:bodyPr/>
           <a:lstStyle/>
           <a:p>
-            <a:endParaRPr lang="de-DE"/>
+            <a:endParaRPr lang="de-DE" dirty="0"/>
           </a:p>
         </p:txBody>
       </p:sp>
@@ -2738,7 +2745,7 @@
               <a:rPr lang="de-DE" smtClean="0"/>
               <a:t>‹#›</a:t>
             </a:fld>
-            <a:endParaRPr lang="de-DE"/>
+            <a:endParaRPr lang="de-DE" dirty="0"/>
           </a:p>
         </p:txBody>
       </p:sp>
@@ -2925,9 +2932,9 @@
           <a:p>
             <a:fld id="{0C105CC3-179F-4A2D-9012-371B48952F93}" type="datetimeFigureOut">
               <a:rPr lang="de-DE" smtClean="0"/>
-              <a:t>17.02.2026</a:t>
+              <a:t>19.02.2026</a:t>
             </a:fld>
-            <a:endParaRPr lang="de-DE"/>
+            <a:endParaRPr lang="de-DE" dirty="0"/>
           </a:p>
         </p:txBody>
       </p:sp>
@@ -2970,7 +2977,7 @@
             </a:lvl1pPr>
           </a:lstStyle>
           <a:p>
-            <a:endParaRPr lang="de-DE"/>
+            <a:endParaRPr lang="de-DE" dirty="0"/>
           </a:p>
         </p:txBody>
       </p:sp>
@@ -3017,7 +3024,7 @@
               <a:rPr lang="de-DE" smtClean="0"/>
               <a:t>‹#›</a:t>
             </a:fld>
-            <a:endParaRPr lang="de-DE"/>
+            <a:endParaRPr lang="de-DE" dirty="0"/>
           </a:p>
         </p:txBody>
       </p:sp>
@@ -3344,10 +3351,10 @@
       </p:grpSpPr>
       <p:pic>
         <p:nvPicPr>
-          <p:cNvPr id="5" name="Picture 4">
-            <a:extLst>
-              <a:ext uri="{FF2B5EF4-FFF2-40B4-BE49-F238E27FC236}">
-                <a16:creationId xmlns:a16="http://schemas.microsoft.com/office/drawing/2014/main" id="{7DCBAF2A-0D68-FE12-8965-5869CD52CCF7}"/>
+          <p:cNvPr id="3" name="Picture 2">
+            <a:extLst>
+              <a:ext uri="{FF2B5EF4-FFF2-40B4-BE49-F238E27FC236}">
+                <a16:creationId xmlns:a16="http://schemas.microsoft.com/office/drawing/2014/main" id="{C6043974-E3F9-C370-8C06-E3E99B060D32}"/>
               </a:ext>
             </a:extLst>
           </p:cNvPr>
@@ -3357,21 +3364,15 @@
           <p:nvPr/>
         </p:nvPicPr>
         <p:blipFill>
-          <a:blip r:embed="rId2">
-            <a:extLst>
-              <a:ext uri="{28A0092B-C50C-407E-A947-70E740481C1C}">
-                <a14:useLocalDpi xmlns:a14="http://schemas.microsoft.com/office/drawing/2010/main" val="0"/>
-              </a:ext>
-            </a:extLst>
-          </a:blip>
+          <a:blip r:embed="rId2"/>
           <a:stretch>
             <a:fillRect/>
           </a:stretch>
         </p:blipFill>
         <p:spPr>
           <a:xfrm>
-            <a:off x="2427012" y="147440"/>
-            <a:ext cx="6540008" cy="6563119"/>
+            <a:off x="0" y="153737"/>
+            <a:ext cx="12192000" cy="6550526"/>
           </a:xfrm>
           <a:prstGeom prst="rect">
             <a:avLst/>
@@ -3380,10 +3381,10 @@
       </p:pic>
       <p:sp>
         <p:nvSpPr>
-          <p:cNvPr id="6" name="Rectangle 5">
-            <a:extLst>
-              <a:ext uri="{FF2B5EF4-FFF2-40B4-BE49-F238E27FC236}">
-                <a16:creationId xmlns:a16="http://schemas.microsoft.com/office/drawing/2014/main" id="{3F84C12B-0DFF-5649-2FC8-5A923CD2B2D6}"/>
+          <p:cNvPr id="4" name="Rectangle 3">
+            <a:extLst>
+              <a:ext uri="{FF2B5EF4-FFF2-40B4-BE49-F238E27FC236}">
+                <a16:creationId xmlns:a16="http://schemas.microsoft.com/office/drawing/2014/main" id="{D13AB461-6CE7-2323-80A8-038719597844}"/>
               </a:ext>
             </a:extLst>
           </p:cNvPr>
@@ -3392,21 +3393,146 @@
         </p:nvSpPr>
         <p:spPr>
           <a:xfrm>
-            <a:off x="2518807" y="4370047"/>
-            <a:ext cx="1419284" cy="701227"/>
+            <a:off x="1424896" y="4686285"/>
+            <a:ext cx="3023692" cy="389616"/>
           </a:xfrm>
           <a:prstGeom prst="rect">
             <a:avLst/>
           </a:prstGeom>
-          <a:noFill/>
+          <a:solidFill>
+            <a:srgbClr val="FFFFFF"/>
+          </a:solidFill>
+          <a:ln>
+            <a:solidFill>
+              <a:srgbClr val="A5355C"/>
+            </a:solidFill>
+          </a:ln>
+        </p:spPr>
+        <p:style>
+          <a:lnRef idx="2">
+            <a:schemeClr val="accent1">
+              <a:shade val="15000"/>
+            </a:schemeClr>
+          </a:lnRef>
+          <a:fillRef idx="1">
+            <a:schemeClr val="accent1"/>
+          </a:fillRef>
+          <a:effectRef idx="0">
+            <a:schemeClr val="accent1"/>
+          </a:effectRef>
+          <a:fontRef idx="minor">
+            <a:schemeClr val="lt1"/>
+          </a:fontRef>
+        </p:style>
+        <p:txBody>
+          <a:bodyPr rtlCol="0" anchor="ctr"/>
+          <a:lstStyle/>
+          <a:p>
+            <a:pPr algn="ctr"/>
+            <a:r>
+              <a:rPr lang="de-DE" dirty="0">
+                <a:solidFill>
+                  <a:srgbClr val="A5355C"/>
+                </a:solidFill>
+                <a:latin typeface="Lucida Console" panose="020B0609040504020204" pitchFamily="49" charset="0"/>
+              </a:rPr>
+              <a:t>login_studio()</a:t>
+            </a:r>
+          </a:p>
+        </p:txBody>
+      </p:sp>
+      <p:sp>
+        <p:nvSpPr>
+          <p:cNvPr id="7" name="Rectangle 6">
+            <a:extLst>
+              <a:ext uri="{FF2B5EF4-FFF2-40B4-BE49-F238E27FC236}">
+                <a16:creationId xmlns:a16="http://schemas.microsoft.com/office/drawing/2014/main" id="{485212D6-46D2-F42D-9E1A-85B018C8347F}"/>
+              </a:ext>
+            </a:extLst>
+          </p:cNvPr>
+          <p:cNvSpPr/>
+          <p:nvPr/>
+        </p:nvSpPr>
+        <p:spPr>
+          <a:xfrm>
+            <a:off x="8072327" y="4686285"/>
+            <a:ext cx="2518968" cy="389616"/>
+          </a:xfrm>
+          <a:prstGeom prst="rect">
+            <a:avLst/>
+          </a:prstGeom>
+          <a:solidFill>
+            <a:srgbClr val="FFFFFF"/>
+          </a:solidFill>
+          <a:ln>
+            <a:solidFill>
+              <a:srgbClr val="A5355C"/>
+            </a:solidFill>
+          </a:ln>
+        </p:spPr>
+        <p:style>
+          <a:lnRef idx="2">
+            <a:schemeClr val="accent1">
+              <a:shade val="15000"/>
+            </a:schemeClr>
+          </a:lnRef>
+          <a:fillRef idx="1">
+            <a:schemeClr val="accent1"/>
+          </a:fillRef>
+          <a:effectRef idx="0">
+            <a:schemeClr val="accent1"/>
+          </a:effectRef>
+          <a:fontRef idx="minor">
+            <a:schemeClr val="lt1"/>
+          </a:fontRef>
+        </p:style>
+        <p:txBody>
+          <a:bodyPr rtlCol="0" anchor="ctr"/>
+          <a:lstStyle/>
+          <a:p>
+            <a:pPr algn="ctr"/>
+            <a:r>
+              <a:rPr lang="de-DE" dirty="0">
+                <a:solidFill>
+                  <a:srgbClr val="A5355C"/>
+                </a:solidFill>
+                <a:latin typeface="Lucida Console" panose="020B0609040504020204" pitchFamily="49" charset="0"/>
+              </a:rPr>
+              <a:t>app_version =</a:t>
+            </a:r>
+          </a:p>
+        </p:txBody>
+      </p:sp>
+      <p:cxnSp>
+        <p:nvCxnSpPr>
+          <p:cNvPr id="9" name="Straight Arrow Connector 8">
+            <a:extLst>
+              <a:ext uri="{FF2B5EF4-FFF2-40B4-BE49-F238E27FC236}">
+                <a16:creationId xmlns:a16="http://schemas.microsoft.com/office/drawing/2014/main" id="{94E5C558-A768-A738-EDF6-36D5CFFDBFAF}"/>
+              </a:ext>
+            </a:extLst>
+          </p:cNvPr>
+          <p:cNvCxnSpPr>
+            <a:cxnSpLocks/>
+          </p:cNvCxnSpPr>
+          <p:nvPr/>
+        </p:nvCxnSpPr>
+        <p:spPr>
+          <a:xfrm>
+            <a:off x="2936742" y="3855904"/>
+            <a:ext cx="0" cy="783612"/>
+          </a:xfrm>
+          <a:prstGeom prst="straightConnector1">
+            <a:avLst/>
+          </a:prstGeom>
           <a:ln w="38100" cap="flat" cmpd="sng" algn="ctr">
             <a:solidFill>
-              <a:srgbClr val="C00000"/>
+              <a:srgbClr val="A5355C"/>
             </a:solidFill>
             <a:prstDash val="solid"/>
             <a:round/>
             <a:headEnd type="none" w="med" len="med"/>
-            <a:tailEnd type="none" w="med" len="med"/>
+            <a:tailEnd type="arrow" w="med" len="med"/>
           </a:ln>
         </p:spPr>
         <p:style>
@@ -3420,22 +3546,571 @@
             <a:scrgbClr r="0" g="0" b="0"/>
           </a:effectRef>
           <a:fontRef idx="minor">
-            <a:schemeClr val="accent2"/>
+            <a:schemeClr val="tx1"/>
           </a:fontRef>
         </p:style>
-        <p:txBody>
-          <a:bodyPr rtlCol="0" anchor="ctr"/>
-          <a:lstStyle/>
-          <a:p>
-            <a:pPr algn="ctr"/>
-            <a:endParaRPr lang="de-DE"/>
-          </a:p>
-        </p:txBody>
-      </p:sp>
+      </p:cxnSp>
+      <p:cxnSp>
+        <p:nvCxnSpPr>
+          <p:cNvPr id="13" name="Straight Arrow Connector 12">
+            <a:extLst>
+              <a:ext uri="{FF2B5EF4-FFF2-40B4-BE49-F238E27FC236}">
+                <a16:creationId xmlns:a16="http://schemas.microsoft.com/office/drawing/2014/main" id="{BA5F3FD5-0608-2943-110D-75FFCEABB626}"/>
+              </a:ext>
+            </a:extLst>
+          </p:cNvPr>
+          <p:cNvCxnSpPr>
+            <a:cxnSpLocks/>
+          </p:cNvCxnSpPr>
+          <p:nvPr/>
+        </p:nvCxnSpPr>
+        <p:spPr>
+          <a:xfrm>
+            <a:off x="7244366" y="4881093"/>
+            <a:ext cx="643944" cy="0"/>
+          </a:xfrm>
+          <a:prstGeom prst="straightConnector1">
+            <a:avLst/>
+          </a:prstGeom>
+          <a:ln w="38100" cap="flat" cmpd="sng" algn="ctr">
+            <a:solidFill>
+              <a:srgbClr val="A5355C"/>
+            </a:solidFill>
+            <a:prstDash val="solid"/>
+            <a:round/>
+            <a:headEnd type="none" w="med" len="med"/>
+            <a:tailEnd type="arrow" w="med" len="med"/>
+          </a:ln>
+        </p:spPr>
+        <p:style>
+          <a:lnRef idx="0">
+            <a:scrgbClr r="0" g="0" b="0"/>
+          </a:lnRef>
+          <a:fillRef idx="0">
+            <a:scrgbClr r="0" g="0" b="0"/>
+          </a:fillRef>
+          <a:effectRef idx="0">
+            <a:scrgbClr r="0" g="0" b="0"/>
+          </a:effectRef>
+          <a:fontRef idx="minor">
+            <a:schemeClr val="tx1"/>
+          </a:fontRef>
+        </p:style>
+      </p:cxnSp>
     </p:spTree>
     <p:extLst>
       <p:ext uri="{BB962C8B-B14F-4D97-AF65-F5344CB8AC3E}">
-        <p14:creationId xmlns:p14="http://schemas.microsoft.com/office/powerpoint/2010/main" val="1102815687"/>
+        <p14:creationId xmlns:p14="http://schemas.microsoft.com/office/powerpoint/2010/main" val="2761877420"/>
+      </p:ext>
+    </p:extLst>
+  </p:cSld>
+  <p:clrMapOvr>
+    <a:masterClrMapping/>
+  </p:clrMapOvr>
+</p:sld>
+</file>
+
+<file path=ppt/slides/slide2.xml><?xml version="1.0" encoding="utf-8"?>
+<p:sld xmlns:a="http://schemas.openxmlformats.org/drawingml/2006/main" xmlns:r="http://schemas.openxmlformats.org/officeDocument/2006/relationships" xmlns:p="http://schemas.openxmlformats.org/presentationml/2006/main">
+  <p:cSld>
+    <p:spTree>
+      <p:nvGrpSpPr>
+        <p:cNvPr id="1" name="">
+          <a:extLst>
+            <a:ext uri="{FF2B5EF4-FFF2-40B4-BE49-F238E27FC236}">
+              <a16:creationId xmlns:a16="http://schemas.microsoft.com/office/drawing/2014/main" id="{2F03F8D4-1409-77AB-53D0-C8896E6AC933}"/>
+            </a:ext>
+          </a:extLst>
+        </p:cNvPr>
+        <p:cNvGrpSpPr/>
+        <p:nvPr/>
+      </p:nvGrpSpPr>
+      <p:grpSpPr>
+        <a:xfrm>
+          <a:off x="0" y="0"/>
+          <a:ext cx="0" cy="0"/>
+          <a:chOff x="0" y="0"/>
+          <a:chExt cx="0" cy="0"/>
+        </a:xfrm>
+      </p:grpSpPr>
+      <p:pic>
+        <p:nvPicPr>
+          <p:cNvPr id="4" name="Picture 3">
+            <a:extLst>
+              <a:ext uri="{FF2B5EF4-FFF2-40B4-BE49-F238E27FC236}">
+                <a16:creationId xmlns:a16="http://schemas.microsoft.com/office/drawing/2014/main" id="{B35CD810-704F-1EB8-7783-AF7B681B13E3}"/>
+              </a:ext>
+            </a:extLst>
+          </p:cNvPr>
+          <p:cNvPicPr>
+            <a:picLocks noChangeAspect="1"/>
+          </p:cNvPicPr>
+          <p:nvPr/>
+        </p:nvPicPr>
+        <p:blipFill>
+          <a:blip r:embed="rId2"/>
+          <a:stretch>
+            <a:fillRect/>
+          </a:stretch>
+        </p:blipFill>
+        <p:spPr>
+          <a:xfrm>
+            <a:off x="269489" y="205258"/>
+            <a:ext cx="5941568" cy="6447484"/>
+          </a:xfrm>
+          <a:prstGeom prst="rect">
+            <a:avLst/>
+          </a:prstGeom>
+        </p:spPr>
+      </p:pic>
+      <p:sp>
+        <p:nvSpPr>
+          <p:cNvPr id="5" name="Rectangle 4">
+            <a:extLst>
+              <a:ext uri="{FF2B5EF4-FFF2-40B4-BE49-F238E27FC236}">
+                <a16:creationId xmlns:a16="http://schemas.microsoft.com/office/drawing/2014/main" id="{B7C630AC-E9C4-B484-9D2A-2BE29BD055F7}"/>
+              </a:ext>
+            </a:extLst>
+          </p:cNvPr>
+          <p:cNvSpPr/>
+          <p:nvPr/>
+        </p:nvSpPr>
+        <p:spPr>
+          <a:xfrm>
+            <a:off x="6699349" y="4704450"/>
+            <a:ext cx="3023692" cy="389616"/>
+          </a:xfrm>
+          <a:prstGeom prst="rect">
+            <a:avLst/>
+          </a:prstGeom>
+          <a:solidFill>
+            <a:srgbClr val="FFFFFF"/>
+          </a:solidFill>
+          <a:ln>
+            <a:solidFill>
+              <a:srgbClr val="A5355C"/>
+            </a:solidFill>
+          </a:ln>
+        </p:spPr>
+        <p:style>
+          <a:lnRef idx="2">
+            <a:schemeClr val="accent1">
+              <a:shade val="15000"/>
+            </a:schemeClr>
+          </a:lnRef>
+          <a:fillRef idx="1">
+            <a:schemeClr val="accent1"/>
+          </a:fillRef>
+          <a:effectRef idx="0">
+            <a:schemeClr val="accent1"/>
+          </a:effectRef>
+          <a:fontRef idx="minor">
+            <a:schemeClr val="lt1"/>
+          </a:fontRef>
+        </p:style>
+        <p:txBody>
+          <a:bodyPr rtlCol="0" anchor="ctr"/>
+          <a:lstStyle/>
+          <a:p>
+            <a:pPr algn="ctr"/>
+            <a:r>
+              <a:rPr lang="de-DE" dirty="0">
+                <a:solidFill>
+                  <a:srgbClr val="A5355C"/>
+                </a:solidFill>
+                <a:latin typeface="Lucida Console" panose="020B0609040504020204" pitchFamily="49" charset="0"/>
+              </a:rPr>
+              <a:t>access_workspace()</a:t>
+            </a:r>
+          </a:p>
+        </p:txBody>
+      </p:sp>
+      <p:sp>
+        <p:nvSpPr>
+          <p:cNvPr id="7" name="Rectangle 6">
+            <a:extLst>
+              <a:ext uri="{FF2B5EF4-FFF2-40B4-BE49-F238E27FC236}">
+                <a16:creationId xmlns:a16="http://schemas.microsoft.com/office/drawing/2014/main" id="{992240E2-73BD-5FD1-7F91-6C0553D8A1BF}"/>
+              </a:ext>
+            </a:extLst>
+          </p:cNvPr>
+          <p:cNvSpPr/>
+          <p:nvPr/>
+        </p:nvSpPr>
+        <p:spPr>
+          <a:xfrm>
+            <a:off x="6699349" y="6237538"/>
+            <a:ext cx="3023692" cy="389616"/>
+          </a:xfrm>
+          <a:prstGeom prst="rect">
+            <a:avLst/>
+          </a:prstGeom>
+          <a:solidFill>
+            <a:srgbClr val="FFFFFF"/>
+          </a:solidFill>
+          <a:ln>
+            <a:solidFill>
+              <a:srgbClr val="A5355C"/>
+            </a:solidFill>
+          </a:ln>
+        </p:spPr>
+        <p:style>
+          <a:lnRef idx="2">
+            <a:schemeClr val="accent1">
+              <a:shade val="15000"/>
+            </a:schemeClr>
+          </a:lnRef>
+          <a:fillRef idx="1">
+            <a:schemeClr val="accent1"/>
+          </a:fillRef>
+          <a:effectRef idx="0">
+            <a:schemeClr val="accent1"/>
+          </a:effectRef>
+          <a:fontRef idx="minor">
+            <a:schemeClr val="lt1"/>
+          </a:fontRef>
+        </p:style>
+        <p:txBody>
+          <a:bodyPr rtlCol="0" anchor="ctr"/>
+          <a:lstStyle/>
+          <a:p>
+            <a:pPr algn="ctr"/>
+            <a:r>
+              <a:rPr lang="de-DE" dirty="0">
+                <a:solidFill>
+                  <a:srgbClr val="A5355C"/>
+                </a:solidFill>
+                <a:latin typeface="Lucida Console" panose="020B0609040504020204" pitchFamily="49" charset="0"/>
+              </a:rPr>
+              <a:t>ws_id = </a:t>
+            </a:r>
+          </a:p>
+        </p:txBody>
+      </p:sp>
+      <p:cxnSp>
+        <p:nvCxnSpPr>
+          <p:cNvPr id="9" name="Straight Arrow Connector 8">
+            <a:extLst>
+              <a:ext uri="{FF2B5EF4-FFF2-40B4-BE49-F238E27FC236}">
+                <a16:creationId xmlns:a16="http://schemas.microsoft.com/office/drawing/2014/main" id="{0DF9B331-FAF6-5BB5-DB22-769EF719971D}"/>
+              </a:ext>
+            </a:extLst>
+          </p:cNvPr>
+          <p:cNvCxnSpPr>
+            <a:cxnSpLocks/>
+          </p:cNvCxnSpPr>
+          <p:nvPr/>
+        </p:nvCxnSpPr>
+        <p:spPr>
+          <a:xfrm>
+            <a:off x="5599099" y="4892948"/>
+            <a:ext cx="995481" cy="0"/>
+          </a:xfrm>
+          <a:prstGeom prst="straightConnector1">
+            <a:avLst/>
+          </a:prstGeom>
+          <a:ln w="38100" cap="flat" cmpd="sng" algn="ctr">
+            <a:solidFill>
+              <a:srgbClr val="A5355C"/>
+            </a:solidFill>
+            <a:prstDash val="solid"/>
+            <a:round/>
+            <a:headEnd type="none" w="med" len="med"/>
+            <a:tailEnd type="arrow" w="med" len="med"/>
+          </a:ln>
+        </p:spPr>
+        <p:style>
+          <a:lnRef idx="0">
+            <a:scrgbClr r="0" g="0" b="0"/>
+          </a:lnRef>
+          <a:fillRef idx="0">
+            <a:scrgbClr r="0" g="0" b="0"/>
+          </a:fillRef>
+          <a:effectRef idx="0">
+            <a:scrgbClr r="0" g="0" b="0"/>
+          </a:effectRef>
+          <a:fontRef idx="minor">
+            <a:schemeClr val="tx1"/>
+          </a:fontRef>
+        </p:style>
+      </p:cxnSp>
+      <p:cxnSp>
+        <p:nvCxnSpPr>
+          <p:cNvPr id="13" name="Straight Arrow Connector 12">
+            <a:extLst>
+              <a:ext uri="{FF2B5EF4-FFF2-40B4-BE49-F238E27FC236}">
+                <a16:creationId xmlns:a16="http://schemas.microsoft.com/office/drawing/2014/main" id="{AE437FDC-A0E9-8B8E-1977-96C131C8C97A}"/>
+              </a:ext>
+            </a:extLst>
+          </p:cNvPr>
+          <p:cNvCxnSpPr>
+            <a:cxnSpLocks/>
+          </p:cNvCxnSpPr>
+          <p:nvPr/>
+        </p:nvCxnSpPr>
+        <p:spPr>
+          <a:xfrm>
+            <a:off x="2132591" y="6445483"/>
+            <a:ext cx="4461989" cy="0"/>
+          </a:xfrm>
+          <a:prstGeom prst="straightConnector1">
+            <a:avLst/>
+          </a:prstGeom>
+          <a:ln w="38100" cap="flat" cmpd="sng" algn="ctr">
+            <a:solidFill>
+              <a:srgbClr val="A5355C"/>
+            </a:solidFill>
+            <a:prstDash val="solid"/>
+            <a:round/>
+            <a:headEnd type="none" w="med" len="med"/>
+            <a:tailEnd type="arrow" w="med" len="med"/>
+          </a:ln>
+        </p:spPr>
+        <p:style>
+          <a:lnRef idx="0">
+            <a:scrgbClr r="0" g="0" b="0"/>
+          </a:lnRef>
+          <a:fillRef idx="0">
+            <a:scrgbClr r="0" g="0" b="0"/>
+          </a:fillRef>
+          <a:effectRef idx="0">
+            <a:scrgbClr r="0" g="0" b="0"/>
+          </a:effectRef>
+          <a:fontRef idx="minor">
+            <a:schemeClr val="tx1"/>
+          </a:fontRef>
+        </p:style>
+      </p:cxnSp>
+      <p:sp>
+        <p:nvSpPr>
+          <p:cNvPr id="15" name="Rectangle 14">
+            <a:extLst>
+              <a:ext uri="{FF2B5EF4-FFF2-40B4-BE49-F238E27FC236}">
+                <a16:creationId xmlns:a16="http://schemas.microsoft.com/office/drawing/2014/main" id="{CC006B1A-D75B-1577-E8AE-1C34AAEA166E}"/>
+              </a:ext>
+            </a:extLst>
+          </p:cNvPr>
+          <p:cNvSpPr/>
+          <p:nvPr/>
+        </p:nvSpPr>
+        <p:spPr>
+          <a:xfrm>
+            <a:off x="1781422" y="6296568"/>
+            <a:ext cx="351169" cy="294382"/>
+          </a:xfrm>
+          <a:prstGeom prst="rect">
+            <a:avLst/>
+          </a:prstGeom>
+          <a:noFill/>
+          <a:ln>
+            <a:solidFill>
+              <a:srgbClr val="A5355C"/>
+            </a:solidFill>
+          </a:ln>
+        </p:spPr>
+        <p:style>
+          <a:lnRef idx="2">
+            <a:schemeClr val="accent1">
+              <a:shade val="15000"/>
+            </a:schemeClr>
+          </a:lnRef>
+          <a:fillRef idx="1">
+            <a:schemeClr val="accent1"/>
+          </a:fillRef>
+          <a:effectRef idx="0">
+            <a:schemeClr val="accent1"/>
+          </a:effectRef>
+          <a:fontRef idx="minor">
+            <a:schemeClr val="lt1"/>
+          </a:fontRef>
+        </p:style>
+        <p:txBody>
+          <a:bodyPr rtlCol="0" anchor="ctr"/>
+          <a:lstStyle/>
+          <a:p>
+            <a:pPr algn="ctr"/>
+            <a:endParaRPr lang="de-DE" dirty="0">
+              <a:solidFill>
+                <a:srgbClr val="A5355C"/>
+              </a:solidFill>
+              <a:latin typeface="Lucida Console" panose="020B0609040504020204" pitchFamily="49" charset="0"/>
+            </a:endParaRPr>
+          </a:p>
+        </p:txBody>
+      </p:sp>
+    </p:spTree>
+    <p:extLst>
+      <p:ext uri="{BB962C8B-B14F-4D97-AF65-F5344CB8AC3E}">
+        <p14:creationId xmlns:p14="http://schemas.microsoft.com/office/powerpoint/2010/main" val="1048404596"/>
+      </p:ext>
+    </p:extLst>
+  </p:cSld>
+  <p:clrMapOvr>
+    <a:masterClrMapping/>
+  </p:clrMapOvr>
+</p:sld>
+</file>
+
+<file path=ppt/slides/slide3.xml><?xml version="1.0" encoding="utf-8"?>
+<p:sld xmlns:a="http://schemas.openxmlformats.org/drawingml/2006/main" xmlns:r="http://schemas.openxmlformats.org/officeDocument/2006/relationships" xmlns:p="http://schemas.openxmlformats.org/presentationml/2006/main">
+  <p:cSld>
+    <p:spTree>
+      <p:nvGrpSpPr>
+        <p:cNvPr id="1" name=""/>
+        <p:cNvGrpSpPr/>
+        <p:nvPr/>
+      </p:nvGrpSpPr>
+      <p:grpSpPr>
+        <a:xfrm>
+          <a:off x="0" y="0"/>
+          <a:ext cx="0" cy="0"/>
+          <a:chOff x="0" y="0"/>
+          <a:chExt cx="0" cy="0"/>
+        </a:xfrm>
+      </p:grpSpPr>
+      <p:pic>
+        <p:nvPicPr>
+          <p:cNvPr id="7" name="Picture 6">
+            <a:extLst>
+              <a:ext uri="{FF2B5EF4-FFF2-40B4-BE49-F238E27FC236}">
+                <a16:creationId xmlns:a16="http://schemas.microsoft.com/office/drawing/2014/main" id="{AE983317-C1DA-1F49-24BD-E6B309A8C826}"/>
+              </a:ext>
+            </a:extLst>
+          </p:cNvPr>
+          <p:cNvPicPr>
+            <a:picLocks noChangeAspect="1"/>
+          </p:cNvPicPr>
+          <p:nvPr/>
+        </p:nvPicPr>
+        <p:blipFill>
+          <a:blip r:embed="rId2"/>
+          <a:stretch>
+            <a:fillRect/>
+          </a:stretch>
+        </p:blipFill>
+        <p:spPr>
+          <a:xfrm>
+            <a:off x="338384" y="0"/>
+            <a:ext cx="7290072" cy="6858000"/>
+          </a:xfrm>
+          <a:prstGeom prst="rect">
+            <a:avLst/>
+          </a:prstGeom>
+        </p:spPr>
+      </p:pic>
+      <p:sp>
+        <p:nvSpPr>
+          <p:cNvPr id="8" name="Rectangle 7">
+            <a:extLst>
+              <a:ext uri="{FF2B5EF4-FFF2-40B4-BE49-F238E27FC236}">
+                <a16:creationId xmlns:a16="http://schemas.microsoft.com/office/drawing/2014/main" id="{BBC20E86-D8B6-2236-BE41-738EE88952D1}"/>
+              </a:ext>
+            </a:extLst>
+          </p:cNvPr>
+          <p:cNvSpPr/>
+          <p:nvPr/>
+        </p:nvSpPr>
+        <p:spPr>
+          <a:xfrm>
+            <a:off x="254405" y="4590938"/>
+            <a:ext cx="1974067" cy="389616"/>
+          </a:xfrm>
+          <a:prstGeom prst="rect">
+            <a:avLst/>
+          </a:prstGeom>
+          <a:solidFill>
+            <a:srgbClr val="FFFFFF"/>
+          </a:solidFill>
+          <a:ln>
+            <a:solidFill>
+              <a:srgbClr val="A5355C"/>
+            </a:solidFill>
+          </a:ln>
+        </p:spPr>
+        <p:style>
+          <a:lnRef idx="2">
+            <a:schemeClr val="accent1">
+              <a:shade val="15000"/>
+            </a:schemeClr>
+          </a:lnRef>
+          <a:fillRef idx="1">
+            <a:schemeClr val="accent1"/>
+          </a:fillRef>
+          <a:effectRef idx="0">
+            <a:schemeClr val="accent1"/>
+          </a:effectRef>
+          <a:fontRef idx="minor">
+            <a:schemeClr val="lt1"/>
+          </a:fontRef>
+        </p:style>
+        <p:txBody>
+          <a:bodyPr rtlCol="0" anchor="ctr"/>
+          <a:lstStyle/>
+          <a:p>
+            <a:pPr algn="ctr"/>
+            <a:r>
+              <a:rPr lang="de-DE" dirty="0">
+                <a:solidFill>
+                  <a:srgbClr val="A5355C"/>
+                </a:solidFill>
+                <a:latin typeface="Lucida Console" panose="020B0609040504020204" pitchFamily="49" charset="0"/>
+              </a:rPr>
+              <a:t>get_units()</a:t>
+            </a:r>
+          </a:p>
+        </p:txBody>
+      </p:sp>
+      <p:cxnSp>
+        <p:nvCxnSpPr>
+          <p:cNvPr id="9" name="Straight Arrow Connector 8">
+            <a:extLst>
+              <a:ext uri="{FF2B5EF4-FFF2-40B4-BE49-F238E27FC236}">
+                <a16:creationId xmlns:a16="http://schemas.microsoft.com/office/drawing/2014/main" id="{05176F0F-1E71-AE69-B2AD-4E11261B9D92}"/>
+              </a:ext>
+            </a:extLst>
+          </p:cNvPr>
+          <p:cNvCxnSpPr>
+            <a:cxnSpLocks/>
+          </p:cNvCxnSpPr>
+          <p:nvPr/>
+        </p:nvCxnSpPr>
+        <p:spPr>
+          <a:xfrm>
+            <a:off x="466659" y="2787741"/>
+            <a:ext cx="0" cy="1752728"/>
+          </a:xfrm>
+          <a:prstGeom prst="straightConnector1">
+            <a:avLst/>
+          </a:prstGeom>
+          <a:ln w="38100" cap="flat" cmpd="sng" algn="ctr">
+            <a:solidFill>
+              <a:srgbClr val="A5355C"/>
+            </a:solidFill>
+            <a:prstDash val="solid"/>
+            <a:round/>
+            <a:headEnd type="none" w="med" len="med"/>
+            <a:tailEnd type="arrow" w="med" len="med"/>
+          </a:ln>
+        </p:spPr>
+        <p:style>
+          <a:lnRef idx="0">
+            <a:scrgbClr r="0" g="0" b="0"/>
+          </a:lnRef>
+          <a:fillRef idx="0">
+            <a:scrgbClr r="0" g="0" b="0"/>
+          </a:fillRef>
+          <a:effectRef idx="0">
+            <a:scrgbClr r="0" g="0" b="0"/>
+          </a:effectRef>
+          <a:fontRef idx="minor">
+            <a:schemeClr val="tx1"/>
+          </a:fontRef>
+        </p:style>
+      </p:cxnSp>
+    </p:spTree>
+    <p:extLst>
+      <p:ext uri="{BB962C8B-B14F-4D97-AF65-F5344CB8AC3E}">
+        <p14:creationId xmlns:p14="http://schemas.microsoft.com/office/powerpoint/2010/main" val="3575408521"/>
       </p:ext>
     </p:extLst>
   </p:cSld>

</xml_diff>

<commit_message>
Describe columns of units object
</commit_message>
<xml_diff>
--- a/vignettes/images/images.pptx
+++ b/vignettes/images/images.pptx
@@ -7,7 +7,8 @@
   <p:sldIdLst>
     <p:sldId id="257" r:id="rId2"/>
     <p:sldId id="258" r:id="rId3"/>
-    <p:sldId id="259" r:id="rId4"/>
+    <p:sldId id="260" r:id="rId4"/>
+    <p:sldId id="261" r:id="rId5"/>
   </p:sldIdLst>
   <p:sldSz cx="12192000" cy="6858000"/>
   <p:notesSz cx="6858000" cy="9144000"/>
@@ -263,7 +264,7 @@
           <a:p>
             <a:fld id="{0C105CC3-179F-4A2D-9012-371B48952F93}" type="datetimeFigureOut">
               <a:rPr lang="de-DE" smtClean="0"/>
-              <a:t>19.02.2026</a:t>
+              <a:t>23.04.2026</a:t>
             </a:fld>
             <a:endParaRPr lang="de-DE" dirty="0"/>
           </a:p>
@@ -463,7 +464,7 @@
           <a:p>
             <a:fld id="{0C105CC3-179F-4A2D-9012-371B48952F93}" type="datetimeFigureOut">
               <a:rPr lang="de-DE" smtClean="0"/>
-              <a:t>19.02.2026</a:t>
+              <a:t>23.04.2026</a:t>
             </a:fld>
             <a:endParaRPr lang="de-DE" dirty="0"/>
           </a:p>
@@ -673,7 +674,7 @@
           <a:p>
             <a:fld id="{0C105CC3-179F-4A2D-9012-371B48952F93}" type="datetimeFigureOut">
               <a:rPr lang="de-DE" smtClean="0"/>
-              <a:t>19.02.2026</a:t>
+              <a:t>23.04.2026</a:t>
             </a:fld>
             <a:endParaRPr lang="de-DE" dirty="0"/>
           </a:p>
@@ -873,7 +874,7 @@
           <a:p>
             <a:fld id="{0C105CC3-179F-4A2D-9012-371B48952F93}" type="datetimeFigureOut">
               <a:rPr lang="de-DE" smtClean="0"/>
-              <a:t>19.02.2026</a:t>
+              <a:t>23.04.2026</a:t>
             </a:fld>
             <a:endParaRPr lang="de-DE" dirty="0"/>
           </a:p>
@@ -1149,7 +1150,7 @@
           <a:p>
             <a:fld id="{0C105CC3-179F-4A2D-9012-371B48952F93}" type="datetimeFigureOut">
               <a:rPr lang="de-DE" smtClean="0"/>
-              <a:t>19.02.2026</a:t>
+              <a:t>23.04.2026</a:t>
             </a:fld>
             <a:endParaRPr lang="de-DE" dirty="0"/>
           </a:p>
@@ -1417,7 +1418,7 @@
           <a:p>
             <a:fld id="{0C105CC3-179F-4A2D-9012-371B48952F93}" type="datetimeFigureOut">
               <a:rPr lang="de-DE" smtClean="0"/>
-              <a:t>19.02.2026</a:t>
+              <a:t>23.04.2026</a:t>
             </a:fld>
             <a:endParaRPr lang="de-DE" dirty="0"/>
           </a:p>
@@ -1832,7 +1833,7 @@
           <a:p>
             <a:fld id="{0C105CC3-179F-4A2D-9012-371B48952F93}" type="datetimeFigureOut">
               <a:rPr lang="de-DE" smtClean="0"/>
-              <a:t>19.02.2026</a:t>
+              <a:t>23.04.2026</a:t>
             </a:fld>
             <a:endParaRPr lang="de-DE" dirty="0"/>
           </a:p>
@@ -1974,7 +1975,7 @@
           <a:p>
             <a:fld id="{0C105CC3-179F-4A2D-9012-371B48952F93}" type="datetimeFigureOut">
               <a:rPr lang="de-DE" smtClean="0"/>
-              <a:t>19.02.2026</a:t>
+              <a:t>23.04.2026</a:t>
             </a:fld>
             <a:endParaRPr lang="de-DE" dirty="0"/>
           </a:p>
@@ -2087,7 +2088,7 @@
           <a:p>
             <a:fld id="{0C105CC3-179F-4A2D-9012-371B48952F93}" type="datetimeFigureOut">
               <a:rPr lang="de-DE" smtClean="0"/>
-              <a:t>19.02.2026</a:t>
+              <a:t>23.04.2026</a:t>
             </a:fld>
             <a:endParaRPr lang="de-DE" dirty="0"/>
           </a:p>
@@ -2400,7 +2401,7 @@
           <a:p>
             <a:fld id="{0C105CC3-179F-4A2D-9012-371B48952F93}" type="datetimeFigureOut">
               <a:rPr lang="de-DE" smtClean="0"/>
-              <a:t>19.02.2026</a:t>
+              <a:t>23.04.2026</a:t>
             </a:fld>
             <a:endParaRPr lang="de-DE" dirty="0"/>
           </a:p>
@@ -2689,7 +2690,7 @@
           <a:p>
             <a:fld id="{0C105CC3-179F-4A2D-9012-371B48952F93}" type="datetimeFigureOut">
               <a:rPr lang="de-DE" smtClean="0"/>
-              <a:t>19.02.2026</a:t>
+              <a:t>23.04.2026</a:t>
             </a:fld>
             <a:endParaRPr lang="de-DE" dirty="0"/>
           </a:p>
@@ -2932,7 +2933,7 @@
           <a:p>
             <a:fld id="{0C105CC3-179F-4A2D-9012-371B48952F93}" type="datetimeFigureOut">
               <a:rPr lang="de-DE" smtClean="0"/>
-              <a:t>19.02.2026</a:t>
+              <a:t>23.04.2026</a:t>
             </a:fld>
             <a:endParaRPr lang="de-DE" dirty="0"/>
           </a:p>
@@ -3492,14 +3493,20 @@
           <a:p>
             <a:pPr algn="ctr"/>
             <a:r>
-              <a:rPr lang="de-DE" dirty="0">
+              <a:rPr lang="de-DE" dirty="0" err="1">
                 <a:solidFill>
                   <a:srgbClr val="A5355C"/>
                 </a:solidFill>
                 <a:latin typeface="Lucida Console" panose="020B0609040504020204" pitchFamily="49" charset="0"/>
               </a:rPr>
-              <a:t>app_version =</a:t>
-            </a:r>
+              <a:t>app_version</a:t>
+            </a:r>
+            <a:endParaRPr lang="de-DE" dirty="0">
+              <a:solidFill>
+                <a:srgbClr val="A5355C"/>
+              </a:solidFill>
+              <a:latin typeface="Lucida Console" panose="020B0609040504020204" pitchFamily="49" charset="0"/>
+            </a:endParaRPr>
           </a:p>
         </p:txBody>
       </p:sp>
@@ -3776,14 +3783,20 @@
           <a:p>
             <a:pPr algn="ctr"/>
             <a:r>
-              <a:rPr lang="de-DE" dirty="0">
+              <a:rPr lang="de-DE" dirty="0" err="1">
                 <a:solidFill>
                   <a:srgbClr val="A5355C"/>
                 </a:solidFill>
                 <a:latin typeface="Lucida Console" panose="020B0609040504020204" pitchFamily="49" charset="0"/>
               </a:rPr>
-              <a:t>ws_id = </a:t>
-            </a:r>
+              <a:t>ws_id</a:t>
+            </a:r>
+            <a:endParaRPr lang="de-DE" dirty="0">
+              <a:solidFill>
+                <a:srgbClr val="A5355C"/>
+              </a:solidFill>
+              <a:latin typeface="Lucida Console" panose="020B0609040504020204" pitchFamily="49" charset="0"/>
+            </a:endParaRPr>
           </a:p>
         </p:txBody>
       </p:sp>
@@ -3938,6 +3951,314 @@
           </a:p>
         </p:txBody>
       </p:sp>
+      <p:cxnSp>
+        <p:nvCxnSpPr>
+          <p:cNvPr id="2" name="Straight Arrow Connector 1">
+            <a:extLst>
+              <a:ext uri="{FF2B5EF4-FFF2-40B4-BE49-F238E27FC236}">
+                <a16:creationId xmlns:a16="http://schemas.microsoft.com/office/drawing/2014/main" id="{06097AF5-B34F-A397-AB98-20A5E33E0F08}"/>
+              </a:ext>
+            </a:extLst>
+          </p:cNvPr>
+          <p:cNvCxnSpPr>
+            <a:cxnSpLocks/>
+          </p:cNvCxnSpPr>
+          <p:nvPr/>
+        </p:nvCxnSpPr>
+        <p:spPr>
+          <a:xfrm>
+            <a:off x="5599099" y="3297664"/>
+            <a:ext cx="995481" cy="0"/>
+          </a:xfrm>
+          <a:prstGeom prst="straightConnector1">
+            <a:avLst/>
+          </a:prstGeom>
+          <a:ln w="38100" cap="flat" cmpd="sng" algn="ctr">
+            <a:solidFill>
+              <a:srgbClr val="A5355C"/>
+            </a:solidFill>
+            <a:prstDash val="solid"/>
+            <a:round/>
+            <a:headEnd type="none" w="med" len="med"/>
+            <a:tailEnd type="arrow" w="med" len="med"/>
+          </a:ln>
+        </p:spPr>
+        <p:style>
+          <a:lnRef idx="0">
+            <a:scrgbClr r="0" g="0" b="0"/>
+          </a:lnRef>
+          <a:fillRef idx="0">
+            <a:scrgbClr r="0" g="0" b="0"/>
+          </a:fillRef>
+          <a:effectRef idx="0">
+            <a:scrgbClr r="0" g="0" b="0"/>
+          </a:effectRef>
+          <a:fontRef idx="minor">
+            <a:schemeClr val="tx1"/>
+          </a:fontRef>
+        </p:style>
+      </p:cxnSp>
+      <p:sp>
+        <p:nvSpPr>
+          <p:cNvPr id="3" name="Rectangle 2">
+            <a:extLst>
+              <a:ext uri="{FF2B5EF4-FFF2-40B4-BE49-F238E27FC236}">
+                <a16:creationId xmlns:a16="http://schemas.microsoft.com/office/drawing/2014/main" id="{F8158EF9-B744-CC87-529A-590869BDFC1A}"/>
+              </a:ext>
+            </a:extLst>
+          </p:cNvPr>
+          <p:cNvSpPr/>
+          <p:nvPr/>
+        </p:nvSpPr>
+        <p:spPr>
+          <a:xfrm>
+            <a:off x="6699349" y="3102856"/>
+            <a:ext cx="3023692" cy="389616"/>
+          </a:xfrm>
+          <a:prstGeom prst="rect">
+            <a:avLst/>
+          </a:prstGeom>
+          <a:solidFill>
+            <a:srgbClr val="FFFFFF"/>
+          </a:solidFill>
+          <a:ln>
+            <a:solidFill>
+              <a:srgbClr val="FFFFFF"/>
+            </a:solidFill>
+          </a:ln>
+        </p:spPr>
+        <p:style>
+          <a:lnRef idx="2">
+            <a:schemeClr val="accent1">
+              <a:shade val="15000"/>
+            </a:schemeClr>
+          </a:lnRef>
+          <a:fillRef idx="1">
+            <a:schemeClr val="accent1"/>
+          </a:fillRef>
+          <a:effectRef idx="0">
+            <a:schemeClr val="accent1"/>
+          </a:effectRef>
+          <a:fontRef idx="minor">
+            <a:schemeClr val="lt1"/>
+          </a:fontRef>
+        </p:style>
+        <p:txBody>
+          <a:bodyPr rtlCol="0" anchor="ctr"/>
+          <a:lstStyle/>
+          <a:p>
+            <a:pPr algn="ctr"/>
+            <a:r>
+              <a:rPr lang="de-DE" dirty="0">
+                <a:solidFill>
+                  <a:srgbClr val="A5355C"/>
+                </a:solidFill>
+                <a:latin typeface="Lucida Console" panose="020B0609040504020204" pitchFamily="49" charset="0"/>
+              </a:rPr>
+              <a:t>This </a:t>
+            </a:r>
+            <a:r>
+              <a:rPr lang="de-DE" dirty="0" err="1">
+                <a:solidFill>
+                  <a:srgbClr val="A5355C"/>
+                </a:solidFill>
+                <a:latin typeface="Lucida Console" panose="020B0609040504020204" pitchFamily="49" charset="0"/>
+              </a:rPr>
+              <a:t>is</a:t>
+            </a:r>
+            <a:r>
+              <a:rPr lang="de-DE" dirty="0">
+                <a:solidFill>
+                  <a:srgbClr val="A5355C"/>
+                </a:solidFill>
+                <a:latin typeface="Lucida Console" panose="020B0609040504020204" pitchFamily="49" charset="0"/>
+              </a:rPr>
+              <a:t> a </a:t>
+            </a:r>
+            <a:r>
+              <a:rPr lang="de-DE" b="1" dirty="0" err="1">
+                <a:solidFill>
+                  <a:srgbClr val="A5355C"/>
+                </a:solidFill>
+                <a:latin typeface="Lucida Console" panose="020B0609040504020204" pitchFamily="49" charset="0"/>
+              </a:rPr>
+              <a:t>workspace</a:t>
+            </a:r>
+            <a:r>
+              <a:rPr lang="de-DE" dirty="0">
+                <a:solidFill>
+                  <a:srgbClr val="A5355C"/>
+                </a:solidFill>
+                <a:latin typeface="Lucida Console" panose="020B0609040504020204" pitchFamily="49" charset="0"/>
+              </a:rPr>
+              <a:t>.</a:t>
+            </a:r>
+          </a:p>
+        </p:txBody>
+      </p:sp>
+      <p:sp>
+        <p:nvSpPr>
+          <p:cNvPr id="6" name="Rectangle 5">
+            <a:extLst>
+              <a:ext uri="{FF2B5EF4-FFF2-40B4-BE49-F238E27FC236}">
+                <a16:creationId xmlns:a16="http://schemas.microsoft.com/office/drawing/2014/main" id="{BF52A213-0F3C-D1C3-17E3-A1877D5246E0}"/>
+              </a:ext>
+            </a:extLst>
+          </p:cNvPr>
+          <p:cNvSpPr/>
+          <p:nvPr/>
+        </p:nvSpPr>
+        <p:spPr>
+          <a:xfrm>
+            <a:off x="6699349" y="2562080"/>
+            <a:ext cx="3807836" cy="389616"/>
+          </a:xfrm>
+          <a:prstGeom prst="rect">
+            <a:avLst/>
+          </a:prstGeom>
+          <a:solidFill>
+            <a:srgbClr val="FFFFFF"/>
+          </a:solidFill>
+          <a:ln>
+            <a:solidFill>
+              <a:srgbClr val="FFFFFF"/>
+            </a:solidFill>
+          </a:ln>
+        </p:spPr>
+        <p:style>
+          <a:lnRef idx="2">
+            <a:schemeClr val="accent1">
+              <a:shade val="15000"/>
+            </a:schemeClr>
+          </a:lnRef>
+          <a:fillRef idx="1">
+            <a:schemeClr val="accent1"/>
+          </a:fillRef>
+          <a:effectRef idx="0">
+            <a:schemeClr val="accent1"/>
+          </a:effectRef>
+          <a:fontRef idx="minor">
+            <a:schemeClr val="lt1"/>
+          </a:fontRef>
+        </p:style>
+        <p:txBody>
+          <a:bodyPr rtlCol="0" anchor="ctr"/>
+          <a:lstStyle/>
+          <a:p>
+            <a:pPr algn="ctr"/>
+            <a:r>
+              <a:rPr lang="de-DE" dirty="0">
+                <a:solidFill>
+                  <a:srgbClr val="A5355C"/>
+                </a:solidFill>
+                <a:latin typeface="Lucida Console" panose="020B0609040504020204" pitchFamily="49" charset="0"/>
+              </a:rPr>
+              <a:t>This </a:t>
+            </a:r>
+            <a:r>
+              <a:rPr lang="de-DE" dirty="0" err="1">
+                <a:solidFill>
+                  <a:srgbClr val="A5355C"/>
+                </a:solidFill>
+                <a:latin typeface="Lucida Console" panose="020B0609040504020204" pitchFamily="49" charset="0"/>
+              </a:rPr>
+              <a:t>is</a:t>
+            </a:r>
+            <a:r>
+              <a:rPr lang="de-DE" dirty="0">
+                <a:solidFill>
+                  <a:srgbClr val="A5355C"/>
+                </a:solidFill>
+                <a:latin typeface="Lucida Console" panose="020B0609040504020204" pitchFamily="49" charset="0"/>
+              </a:rPr>
+              <a:t> a </a:t>
+            </a:r>
+            <a:r>
+              <a:rPr lang="de-DE" b="1" dirty="0" err="1">
+                <a:solidFill>
+                  <a:srgbClr val="A5355C"/>
+                </a:solidFill>
+                <a:latin typeface="Lucida Console" panose="020B0609040504020204" pitchFamily="49" charset="0"/>
+              </a:rPr>
+              <a:t>workspace</a:t>
+            </a:r>
+            <a:r>
+              <a:rPr lang="de-DE" b="1" dirty="0">
+                <a:solidFill>
+                  <a:srgbClr val="A5355C"/>
+                </a:solidFill>
+                <a:latin typeface="Lucida Console" panose="020B0609040504020204" pitchFamily="49" charset="0"/>
+              </a:rPr>
+              <a:t> </a:t>
+            </a:r>
+            <a:r>
+              <a:rPr lang="de-DE" b="1" dirty="0" err="1">
+                <a:solidFill>
+                  <a:srgbClr val="A5355C"/>
+                </a:solidFill>
+                <a:latin typeface="Lucida Console" panose="020B0609040504020204" pitchFamily="49" charset="0"/>
+              </a:rPr>
+              <a:t>group</a:t>
+            </a:r>
+            <a:r>
+              <a:rPr lang="de-DE" dirty="0">
+                <a:solidFill>
+                  <a:srgbClr val="A5355C"/>
+                </a:solidFill>
+                <a:latin typeface="Lucida Console" panose="020B0609040504020204" pitchFamily="49" charset="0"/>
+              </a:rPr>
+              <a:t>.</a:t>
+            </a:r>
+          </a:p>
+        </p:txBody>
+      </p:sp>
+      <p:cxnSp>
+        <p:nvCxnSpPr>
+          <p:cNvPr id="8" name="Straight Arrow Connector 7">
+            <a:extLst>
+              <a:ext uri="{FF2B5EF4-FFF2-40B4-BE49-F238E27FC236}">
+                <a16:creationId xmlns:a16="http://schemas.microsoft.com/office/drawing/2014/main" id="{06861F02-02BB-1CBD-147E-2716CE2ACD9E}"/>
+              </a:ext>
+            </a:extLst>
+          </p:cNvPr>
+          <p:cNvCxnSpPr>
+            <a:cxnSpLocks/>
+          </p:cNvCxnSpPr>
+          <p:nvPr/>
+        </p:nvCxnSpPr>
+        <p:spPr>
+          <a:xfrm>
+            <a:off x="5598259" y="2764264"/>
+            <a:ext cx="995481" cy="0"/>
+          </a:xfrm>
+          <a:prstGeom prst="straightConnector1">
+            <a:avLst/>
+          </a:prstGeom>
+          <a:ln w="38100" cap="flat" cmpd="sng" algn="ctr">
+            <a:solidFill>
+              <a:srgbClr val="A5355C"/>
+            </a:solidFill>
+            <a:prstDash val="solid"/>
+            <a:round/>
+            <a:headEnd type="none" w="med" len="med"/>
+            <a:tailEnd type="arrow" w="med" len="med"/>
+          </a:ln>
+        </p:spPr>
+        <p:style>
+          <a:lnRef idx="0">
+            <a:scrgbClr r="0" g="0" b="0"/>
+          </a:lnRef>
+          <a:fillRef idx="0">
+            <a:scrgbClr r="0" g="0" b="0"/>
+          </a:fillRef>
+          <a:effectRef idx="0">
+            <a:scrgbClr r="0" g="0" b="0"/>
+          </a:effectRef>
+          <a:fontRef idx="minor">
+            <a:schemeClr val="tx1"/>
+          </a:fontRef>
+        </p:style>
+      </p:cxnSp>
     </p:spTree>
     <p:extLst>
       <p:ext uri="{BB962C8B-B14F-4D97-AF65-F5344CB8AC3E}">
@@ -3970,10 +4291,10 @@
       </p:grpSpPr>
       <p:pic>
         <p:nvPicPr>
-          <p:cNvPr id="7" name="Picture 6">
-            <a:extLst>
-              <a:ext uri="{FF2B5EF4-FFF2-40B4-BE49-F238E27FC236}">
-                <a16:creationId xmlns:a16="http://schemas.microsoft.com/office/drawing/2014/main" id="{AE983317-C1DA-1F49-24BD-E6B309A8C826}"/>
+          <p:cNvPr id="5" name="Picture 4">
+            <a:extLst>
+              <a:ext uri="{FF2B5EF4-FFF2-40B4-BE49-F238E27FC236}">
+                <a16:creationId xmlns:a16="http://schemas.microsoft.com/office/drawing/2014/main" id="{0FAB521A-5E8D-4FBF-84B8-6D8BCED9EA30}"/>
               </a:ext>
             </a:extLst>
           </p:cNvPr>
@@ -3990,127 +4311,78 @@
         </p:blipFill>
         <p:spPr>
           <a:xfrm>
-            <a:off x="338384" y="0"/>
-            <a:ext cx="7290072" cy="6858000"/>
+            <a:off x="222880" y="212202"/>
+            <a:ext cx="9266807" cy="6415482"/>
           </a:xfrm>
           <a:prstGeom prst="rect">
             <a:avLst/>
           </a:prstGeom>
         </p:spPr>
       </p:pic>
-      <p:sp>
-        <p:nvSpPr>
-          <p:cNvPr id="8" name="Rectangle 7">
-            <a:extLst>
-              <a:ext uri="{FF2B5EF4-FFF2-40B4-BE49-F238E27FC236}">
-                <a16:creationId xmlns:a16="http://schemas.microsoft.com/office/drawing/2014/main" id="{BBC20E86-D8B6-2236-BE41-738EE88952D1}"/>
-              </a:ext>
-            </a:extLst>
-          </p:cNvPr>
-          <p:cNvSpPr/>
+    </p:spTree>
+    <p:extLst>
+      <p:ext uri="{BB962C8B-B14F-4D97-AF65-F5344CB8AC3E}">
+        <p14:creationId xmlns:p14="http://schemas.microsoft.com/office/powerpoint/2010/main" val="219880829"/>
+      </p:ext>
+    </p:extLst>
+  </p:cSld>
+  <p:clrMapOvr>
+    <a:masterClrMapping/>
+  </p:clrMapOvr>
+</p:sld>
+</file>
+
+<file path=ppt/slides/slide4.xml><?xml version="1.0" encoding="utf-8"?>
+<p:sld xmlns:a="http://schemas.openxmlformats.org/drawingml/2006/main" xmlns:r="http://schemas.openxmlformats.org/officeDocument/2006/relationships" xmlns:p="http://schemas.openxmlformats.org/presentationml/2006/main">
+  <p:cSld>
+    <p:spTree>
+      <p:nvGrpSpPr>
+        <p:cNvPr id="1" name=""/>
+        <p:cNvGrpSpPr/>
+        <p:nvPr/>
+      </p:nvGrpSpPr>
+      <p:grpSpPr>
+        <a:xfrm>
+          <a:off x="0" y="0"/>
+          <a:ext cx="0" cy="0"/>
+          <a:chOff x="0" y="0"/>
+          <a:chExt cx="0" cy="0"/>
+        </a:xfrm>
+      </p:grpSpPr>
+      <p:pic>
+        <p:nvPicPr>
+          <p:cNvPr id="5" name="Picture 4">
+            <a:extLst>
+              <a:ext uri="{FF2B5EF4-FFF2-40B4-BE49-F238E27FC236}">
+                <a16:creationId xmlns:a16="http://schemas.microsoft.com/office/drawing/2014/main" id="{9C82BC31-489B-6C26-2A90-15369314E9D0}"/>
+              </a:ext>
+            </a:extLst>
+          </p:cNvPr>
+          <p:cNvPicPr>
+            <a:picLocks noChangeAspect="1"/>
+          </p:cNvPicPr>
           <p:nvPr/>
-        </p:nvSpPr>
+        </p:nvPicPr>
+        <p:blipFill>
+          <a:blip r:embed="rId2"/>
+          <a:stretch>
+            <a:fillRect/>
+          </a:stretch>
+        </p:blipFill>
         <p:spPr>
           <a:xfrm>
-            <a:off x="254405" y="4590938"/>
-            <a:ext cx="1974067" cy="389616"/>
+            <a:off x="1522241" y="1218572"/>
+            <a:ext cx="9147518" cy="3999865"/>
           </a:xfrm>
           <a:prstGeom prst="rect">
             <a:avLst/>
           </a:prstGeom>
-          <a:solidFill>
-            <a:srgbClr val="FFFFFF"/>
-          </a:solidFill>
-          <a:ln>
-            <a:solidFill>
-              <a:srgbClr val="A5355C"/>
-            </a:solidFill>
-          </a:ln>
         </p:spPr>
-        <p:style>
-          <a:lnRef idx="2">
-            <a:schemeClr val="accent1">
-              <a:shade val="15000"/>
-            </a:schemeClr>
-          </a:lnRef>
-          <a:fillRef idx="1">
-            <a:schemeClr val="accent1"/>
-          </a:fillRef>
-          <a:effectRef idx="0">
-            <a:schemeClr val="accent1"/>
-          </a:effectRef>
-          <a:fontRef idx="minor">
-            <a:schemeClr val="lt1"/>
-          </a:fontRef>
-        </p:style>
-        <p:txBody>
-          <a:bodyPr rtlCol="0" anchor="ctr"/>
-          <a:lstStyle/>
-          <a:p>
-            <a:pPr algn="ctr"/>
-            <a:r>
-              <a:rPr lang="de-DE" dirty="0">
-                <a:solidFill>
-                  <a:srgbClr val="A5355C"/>
-                </a:solidFill>
-                <a:latin typeface="Lucida Console" panose="020B0609040504020204" pitchFamily="49" charset="0"/>
-              </a:rPr>
-              <a:t>get_units()</a:t>
-            </a:r>
-          </a:p>
-        </p:txBody>
-      </p:sp>
-      <p:cxnSp>
-        <p:nvCxnSpPr>
-          <p:cNvPr id="9" name="Straight Arrow Connector 8">
-            <a:extLst>
-              <a:ext uri="{FF2B5EF4-FFF2-40B4-BE49-F238E27FC236}">
-                <a16:creationId xmlns:a16="http://schemas.microsoft.com/office/drawing/2014/main" id="{05176F0F-1E71-AE69-B2AD-4E11261B9D92}"/>
-              </a:ext>
-            </a:extLst>
-          </p:cNvPr>
-          <p:cNvCxnSpPr>
-            <a:cxnSpLocks/>
-          </p:cNvCxnSpPr>
-          <p:nvPr/>
-        </p:nvCxnSpPr>
-        <p:spPr>
-          <a:xfrm>
-            <a:off x="466659" y="2787741"/>
-            <a:ext cx="0" cy="1752728"/>
-          </a:xfrm>
-          <a:prstGeom prst="straightConnector1">
-            <a:avLst/>
-          </a:prstGeom>
-          <a:ln w="38100" cap="flat" cmpd="sng" algn="ctr">
-            <a:solidFill>
-              <a:srgbClr val="A5355C"/>
-            </a:solidFill>
-            <a:prstDash val="solid"/>
-            <a:round/>
-            <a:headEnd type="none" w="med" len="med"/>
-            <a:tailEnd type="arrow" w="med" len="med"/>
-          </a:ln>
-        </p:spPr>
-        <p:style>
-          <a:lnRef idx="0">
-            <a:scrgbClr r="0" g="0" b="0"/>
-          </a:lnRef>
-          <a:fillRef idx="0">
-            <a:scrgbClr r="0" g="0" b="0"/>
-          </a:fillRef>
-          <a:effectRef idx="0">
-            <a:scrgbClr r="0" g="0" b="0"/>
-          </a:effectRef>
-          <a:fontRef idx="minor">
-            <a:schemeClr val="tx1"/>
-          </a:fontRef>
-        </p:style>
-      </p:cxnSp>
+      </p:pic>
     </p:spTree>
     <p:extLst>
       <p:ext uri="{BB962C8B-B14F-4D97-AF65-F5344CB8AC3E}">
-        <p14:creationId xmlns:p14="http://schemas.microsoft.com/office/powerpoint/2010/main" val="3575408521"/>
+        <p14:creationId xmlns:p14="http://schemas.microsoft.com/office/powerpoint/2010/main" val="3407849585"/>
       </p:ext>
     </p:extLst>
   </p:cSld>

</xml_diff>

<commit_message>
Add browser tools screenshot
</commit_message>
<xml_diff>
--- a/vignettes/images/images.pptx
+++ b/vignettes/images/images.pptx
@@ -5,7 +5,7 @@
     <p:sldMasterId id="2147483648" r:id="rId1"/>
   </p:sldMasterIdLst>
   <p:notesMasterIdLst>
-    <p:notesMasterId r:id="rId8"/>
+    <p:notesMasterId r:id="rId9"/>
   </p:notesMasterIdLst>
   <p:sldIdLst>
     <p:sldId id="257" r:id="rId2"/>
@@ -14,6 +14,7 @@
     <p:sldId id="261" r:id="rId5"/>
     <p:sldId id="262" r:id="rId6"/>
     <p:sldId id="264" r:id="rId7"/>
+    <p:sldId id="265" r:id="rId8"/>
   </p:sldIdLst>
   <p:sldSz cx="12192000" cy="6858000"/>
   <p:notesSz cx="6858000" cy="9144000"/>
@@ -202,7 +203,7 @@
           <a:p>
             <a:fld id="{47B53907-AE11-4DB4-A650-AEF08113A763}" type="datetimeFigureOut">
               <a:rPr lang="de-DE" smtClean="0"/>
-              <a:t>13.05.2026</a:t>
+              <a:t>22.06.2026</a:t>
             </a:fld>
             <a:endParaRPr lang="de-DE"/>
           </a:p>
@@ -811,7 +812,7 @@
           <a:p>
             <a:fld id="{0C105CC3-179F-4A2D-9012-371B48952F93}" type="datetimeFigureOut">
               <a:rPr lang="de-DE" smtClean="0"/>
-              <a:t>13.05.2026</a:t>
+              <a:t>22.06.2026</a:t>
             </a:fld>
             <a:endParaRPr lang="de-DE" dirty="0"/>
           </a:p>
@@ -1011,7 +1012,7 @@
           <a:p>
             <a:fld id="{0C105CC3-179F-4A2D-9012-371B48952F93}" type="datetimeFigureOut">
               <a:rPr lang="de-DE" smtClean="0"/>
-              <a:t>13.05.2026</a:t>
+              <a:t>22.06.2026</a:t>
             </a:fld>
             <a:endParaRPr lang="de-DE" dirty="0"/>
           </a:p>
@@ -1221,7 +1222,7 @@
           <a:p>
             <a:fld id="{0C105CC3-179F-4A2D-9012-371B48952F93}" type="datetimeFigureOut">
               <a:rPr lang="de-DE" smtClean="0"/>
-              <a:t>13.05.2026</a:t>
+              <a:t>22.06.2026</a:t>
             </a:fld>
             <a:endParaRPr lang="de-DE" dirty="0"/>
           </a:p>
@@ -1421,7 +1422,7 @@
           <a:p>
             <a:fld id="{0C105CC3-179F-4A2D-9012-371B48952F93}" type="datetimeFigureOut">
               <a:rPr lang="de-DE" smtClean="0"/>
-              <a:t>13.05.2026</a:t>
+              <a:t>22.06.2026</a:t>
             </a:fld>
             <a:endParaRPr lang="de-DE" dirty="0"/>
           </a:p>
@@ -1697,7 +1698,7 @@
           <a:p>
             <a:fld id="{0C105CC3-179F-4A2D-9012-371B48952F93}" type="datetimeFigureOut">
               <a:rPr lang="de-DE" smtClean="0"/>
-              <a:t>13.05.2026</a:t>
+              <a:t>22.06.2026</a:t>
             </a:fld>
             <a:endParaRPr lang="de-DE" dirty="0"/>
           </a:p>
@@ -1965,7 +1966,7 @@
           <a:p>
             <a:fld id="{0C105CC3-179F-4A2D-9012-371B48952F93}" type="datetimeFigureOut">
               <a:rPr lang="de-DE" smtClean="0"/>
-              <a:t>13.05.2026</a:t>
+              <a:t>22.06.2026</a:t>
             </a:fld>
             <a:endParaRPr lang="de-DE" dirty="0"/>
           </a:p>
@@ -2380,7 +2381,7 @@
           <a:p>
             <a:fld id="{0C105CC3-179F-4A2D-9012-371B48952F93}" type="datetimeFigureOut">
               <a:rPr lang="de-DE" smtClean="0"/>
-              <a:t>13.05.2026</a:t>
+              <a:t>22.06.2026</a:t>
             </a:fld>
             <a:endParaRPr lang="de-DE" dirty="0"/>
           </a:p>
@@ -2522,7 +2523,7 @@
           <a:p>
             <a:fld id="{0C105CC3-179F-4A2D-9012-371B48952F93}" type="datetimeFigureOut">
               <a:rPr lang="de-DE" smtClean="0"/>
-              <a:t>13.05.2026</a:t>
+              <a:t>22.06.2026</a:t>
             </a:fld>
             <a:endParaRPr lang="de-DE" dirty="0"/>
           </a:p>
@@ -2635,7 +2636,7 @@
           <a:p>
             <a:fld id="{0C105CC3-179F-4A2D-9012-371B48952F93}" type="datetimeFigureOut">
               <a:rPr lang="de-DE" smtClean="0"/>
-              <a:t>13.05.2026</a:t>
+              <a:t>22.06.2026</a:t>
             </a:fld>
             <a:endParaRPr lang="de-DE" dirty="0"/>
           </a:p>
@@ -2948,7 +2949,7 @@
           <a:p>
             <a:fld id="{0C105CC3-179F-4A2D-9012-371B48952F93}" type="datetimeFigureOut">
               <a:rPr lang="de-DE" smtClean="0"/>
-              <a:t>13.05.2026</a:t>
+              <a:t>22.06.2026</a:t>
             </a:fld>
             <a:endParaRPr lang="de-DE" dirty="0"/>
           </a:p>
@@ -3237,7 +3238,7 @@
           <a:p>
             <a:fld id="{0C105CC3-179F-4A2D-9012-371B48952F93}" type="datetimeFigureOut">
               <a:rPr lang="de-DE" smtClean="0"/>
-              <a:t>13.05.2026</a:t>
+              <a:t>22.06.2026</a:t>
             </a:fld>
             <a:endParaRPr lang="de-DE" dirty="0"/>
           </a:p>
@@ -3480,7 +3481,7 @@
           <a:p>
             <a:fld id="{0C105CC3-179F-4A2D-9012-371B48952F93}" type="datetimeFigureOut">
               <a:rPr lang="de-DE" smtClean="0"/>
-              <a:t>13.05.2026</a:t>
+              <a:t>22.06.2026</a:t>
             </a:fld>
             <a:endParaRPr lang="de-DE" dirty="0"/>
           </a:p>
@@ -7997,6 +7998,1097 @@
     <p:extLst>
       <p:ext uri="{BB962C8B-B14F-4D97-AF65-F5344CB8AC3E}">
         <p14:creationId xmlns:p14="http://schemas.microsoft.com/office/powerpoint/2010/main" val="1029399752"/>
+      </p:ext>
+    </p:extLst>
+  </p:cSld>
+  <p:clrMapOvr>
+    <a:masterClrMapping/>
+  </p:clrMapOvr>
+</p:sld>
+</file>
+
+<file path=ppt/slides/slide7.xml><?xml version="1.0" encoding="utf-8"?>
+<p:sld xmlns:a="http://schemas.openxmlformats.org/drawingml/2006/main" xmlns:r="http://schemas.openxmlformats.org/officeDocument/2006/relationships" xmlns:p="http://schemas.openxmlformats.org/presentationml/2006/main">
+  <p:cSld>
+    <p:spTree>
+      <p:nvGrpSpPr>
+        <p:cNvPr id="1" name=""/>
+        <p:cNvGrpSpPr/>
+        <p:nvPr/>
+      </p:nvGrpSpPr>
+      <p:grpSpPr>
+        <a:xfrm>
+          <a:off x="0" y="0"/>
+          <a:ext cx="0" cy="0"/>
+          <a:chOff x="0" y="0"/>
+          <a:chExt cx="0" cy="0"/>
+        </a:xfrm>
+      </p:grpSpPr>
+      <p:pic>
+        <p:nvPicPr>
+          <p:cNvPr id="5" name="Picture 4">
+            <a:extLst>
+              <a:ext uri="{FF2B5EF4-FFF2-40B4-BE49-F238E27FC236}">
+                <a16:creationId xmlns:a16="http://schemas.microsoft.com/office/drawing/2014/main" id="{F48F3376-E36D-673A-D35F-683D7C10F499}"/>
+              </a:ext>
+            </a:extLst>
+          </p:cNvPr>
+          <p:cNvPicPr>
+            <a:picLocks noChangeAspect="1"/>
+          </p:cNvPicPr>
+          <p:nvPr/>
+        </p:nvPicPr>
+        <p:blipFill>
+          <a:blip r:embed="rId2"/>
+          <a:stretch>
+            <a:fillRect/>
+          </a:stretch>
+        </p:blipFill>
+        <p:spPr>
+          <a:xfrm>
+            <a:off x="395748" y="1876129"/>
+            <a:ext cx="11400503" cy="2983465"/>
+          </a:xfrm>
+          <a:prstGeom prst="rect">
+            <a:avLst/>
+          </a:prstGeom>
+        </p:spPr>
+      </p:pic>
+      <p:sp>
+        <p:nvSpPr>
+          <p:cNvPr id="8" name="Rectangle 7">
+            <a:extLst>
+              <a:ext uri="{FF2B5EF4-FFF2-40B4-BE49-F238E27FC236}">
+                <a16:creationId xmlns:a16="http://schemas.microsoft.com/office/drawing/2014/main" id="{D32DCBAE-F146-8F3A-58EA-BD3DFB362ED8}"/>
+              </a:ext>
+            </a:extLst>
+          </p:cNvPr>
+          <p:cNvSpPr/>
+          <p:nvPr/>
+        </p:nvSpPr>
+        <p:spPr>
+          <a:xfrm>
+            <a:off x="5919584" y="368787"/>
+            <a:ext cx="6094769" cy="389616"/>
+          </a:xfrm>
+          <a:prstGeom prst="rect">
+            <a:avLst/>
+          </a:prstGeom>
+          <a:solidFill>
+            <a:srgbClr val="FFFFFF"/>
+          </a:solidFill>
+          <a:ln>
+            <a:solidFill>
+              <a:srgbClr val="FFFFFF"/>
+            </a:solidFill>
+          </a:ln>
+        </p:spPr>
+        <p:style>
+          <a:lnRef idx="2">
+            <a:schemeClr val="accent1">
+              <a:shade val="15000"/>
+            </a:schemeClr>
+          </a:lnRef>
+          <a:fillRef idx="1">
+            <a:schemeClr val="accent1"/>
+          </a:fillRef>
+          <a:effectRef idx="0">
+            <a:schemeClr val="accent1"/>
+          </a:effectRef>
+          <a:fontRef idx="minor">
+            <a:schemeClr val="lt1"/>
+          </a:fontRef>
+        </p:style>
+        <p:txBody>
+          <a:bodyPr rtlCol="0" anchor="ctr"/>
+          <a:lstStyle/>
+          <a:p>
+            <a:pPr algn="ctr"/>
+            <a:r>
+              <a:rPr lang="de-DE" dirty="0">
+                <a:solidFill>
+                  <a:srgbClr val="A5355C"/>
+                </a:solidFill>
+                <a:latin typeface="Lucida Console" panose="020B0609040504020204" pitchFamily="49" charset="0"/>
+              </a:rPr>
+              <a:t>The </a:t>
+            </a:r>
+            <a:r>
+              <a:rPr lang="de-DE" dirty="0" err="1">
+                <a:solidFill>
+                  <a:srgbClr val="A5355C"/>
+                </a:solidFill>
+                <a:latin typeface="Lucida Console" panose="020B0609040504020204" pitchFamily="49" charset="0"/>
+              </a:rPr>
+              <a:t>browser</a:t>
+            </a:r>
+            <a:r>
+              <a:rPr lang="de-DE" dirty="0">
+                <a:solidFill>
+                  <a:srgbClr val="A5355C"/>
+                </a:solidFill>
+                <a:latin typeface="Lucida Console" panose="020B0609040504020204" pitchFamily="49" charset="0"/>
+              </a:rPr>
+              <a:t> </a:t>
+            </a:r>
+            <a:r>
+              <a:rPr lang="de-DE" dirty="0" err="1">
+                <a:solidFill>
+                  <a:srgbClr val="A5355C"/>
+                </a:solidFill>
+                <a:latin typeface="Lucida Console" panose="020B0609040504020204" pitchFamily="49" charset="0"/>
+              </a:rPr>
+              <a:t>asked</a:t>
+            </a:r>
+            <a:r>
+              <a:rPr lang="de-DE" dirty="0">
+                <a:solidFill>
+                  <a:srgbClr val="A5355C"/>
+                </a:solidFill>
+                <a:latin typeface="Lucida Console" panose="020B0609040504020204" pitchFamily="49" charset="0"/>
+              </a:rPr>
+              <a:t> </a:t>
+            </a:r>
+            <a:r>
+              <a:rPr lang="de-DE" dirty="0" err="1">
+                <a:solidFill>
+                  <a:srgbClr val="A5355C"/>
+                </a:solidFill>
+                <a:latin typeface="Lucida Console" panose="020B0609040504020204" pitchFamily="49" charset="0"/>
+              </a:rPr>
+              <a:t>the</a:t>
+            </a:r>
+            <a:r>
+              <a:rPr lang="de-DE" dirty="0">
+                <a:solidFill>
+                  <a:srgbClr val="A5355C"/>
+                </a:solidFill>
+                <a:latin typeface="Lucida Console" panose="020B0609040504020204" pitchFamily="49" charset="0"/>
+              </a:rPr>
+              <a:t> IQB Studio </a:t>
+            </a:r>
+            <a:r>
+              <a:rPr lang="de-DE" dirty="0" err="1">
+                <a:solidFill>
+                  <a:srgbClr val="A5355C"/>
+                </a:solidFill>
+                <a:latin typeface="Lucida Console" panose="020B0609040504020204" pitchFamily="49" charset="0"/>
+              </a:rPr>
+              <a:t>server</a:t>
+            </a:r>
+            <a:r>
+              <a:rPr lang="de-DE" dirty="0">
+                <a:solidFill>
+                  <a:srgbClr val="A5355C"/>
+                </a:solidFill>
+                <a:latin typeface="Lucida Console" panose="020B0609040504020204" pitchFamily="49" charset="0"/>
+              </a:rPr>
+              <a:t> </a:t>
+            </a:r>
+            <a:r>
+              <a:rPr lang="de-DE" dirty="0" err="1">
+                <a:solidFill>
+                  <a:srgbClr val="A5355C"/>
+                </a:solidFill>
+                <a:latin typeface="Lucida Console" panose="020B0609040504020204" pitchFamily="49" charset="0"/>
+              </a:rPr>
+              <a:t>for</a:t>
+            </a:r>
+            <a:r>
+              <a:rPr lang="de-DE" dirty="0">
+                <a:solidFill>
+                  <a:srgbClr val="A5355C"/>
+                </a:solidFill>
+                <a:latin typeface="Lucida Console" panose="020B0609040504020204" pitchFamily="49" charset="0"/>
+              </a:rPr>
+              <a:t> </a:t>
+            </a:r>
+            <a:r>
+              <a:rPr lang="de-DE" dirty="0" err="1">
+                <a:solidFill>
+                  <a:srgbClr val="A5355C"/>
+                </a:solidFill>
+                <a:latin typeface="Lucida Console" panose="020B0609040504020204" pitchFamily="49" charset="0"/>
+              </a:rPr>
+              <a:t>the</a:t>
+            </a:r>
+            <a:r>
+              <a:rPr lang="de-DE" dirty="0">
+                <a:solidFill>
+                  <a:srgbClr val="A5355C"/>
+                </a:solidFill>
+                <a:latin typeface="Lucida Console" panose="020B0609040504020204" pitchFamily="49" charset="0"/>
+              </a:rPr>
+              <a:t> </a:t>
+            </a:r>
+            <a:r>
+              <a:rPr lang="de-DE" b="1" dirty="0" err="1">
+                <a:solidFill>
+                  <a:srgbClr val="A5355C"/>
+                </a:solidFill>
+                <a:latin typeface="Lucida Console" panose="020B0609040504020204" pitchFamily="49" charset="0"/>
+              </a:rPr>
+              <a:t>unit</a:t>
+            </a:r>
+            <a:r>
+              <a:rPr lang="de-DE" b="1" dirty="0">
+                <a:solidFill>
+                  <a:srgbClr val="A5355C"/>
+                </a:solidFill>
+                <a:latin typeface="Lucida Console" panose="020B0609040504020204" pitchFamily="49" charset="0"/>
+              </a:rPr>
+              <a:t> </a:t>
+            </a:r>
+            <a:r>
+              <a:rPr lang="de-DE" b="1" dirty="0" err="1">
+                <a:solidFill>
+                  <a:srgbClr val="A5355C"/>
+                </a:solidFill>
+                <a:latin typeface="Lucida Console" panose="020B0609040504020204" pitchFamily="49" charset="0"/>
+              </a:rPr>
+              <a:t>list</a:t>
+            </a:r>
+            <a:r>
+              <a:rPr lang="de-DE" b="1" dirty="0">
+                <a:solidFill>
+                  <a:srgbClr val="A5355C"/>
+                </a:solidFill>
+                <a:latin typeface="Lucida Console" panose="020B0609040504020204" pitchFamily="49" charset="0"/>
+              </a:rPr>
+              <a:t> </a:t>
+            </a:r>
+            <a:r>
+              <a:rPr lang="de-DE" b="1" dirty="0" err="1">
+                <a:solidFill>
+                  <a:srgbClr val="A5355C"/>
+                </a:solidFill>
+                <a:latin typeface="Lucida Console" panose="020B0609040504020204" pitchFamily="49" charset="0"/>
+              </a:rPr>
+              <a:t>of</a:t>
+            </a:r>
+            <a:r>
+              <a:rPr lang="de-DE" b="1" dirty="0">
+                <a:solidFill>
+                  <a:srgbClr val="A5355C"/>
+                </a:solidFill>
+                <a:latin typeface="Lucida Console" panose="020B0609040504020204" pitchFamily="49" charset="0"/>
+              </a:rPr>
+              <a:t> </a:t>
+            </a:r>
+            <a:r>
+              <a:rPr lang="de-DE" b="1" dirty="0" err="1">
+                <a:solidFill>
+                  <a:srgbClr val="A5355C"/>
+                </a:solidFill>
+                <a:latin typeface="Lucida Console" panose="020B0609040504020204" pitchFamily="49" charset="0"/>
+              </a:rPr>
+              <a:t>workspace</a:t>
+            </a:r>
+            <a:r>
+              <a:rPr lang="de-DE" b="1" dirty="0">
+                <a:solidFill>
+                  <a:srgbClr val="A5355C"/>
+                </a:solidFill>
+                <a:latin typeface="Lucida Console" panose="020B0609040504020204" pitchFamily="49" charset="0"/>
+              </a:rPr>
+              <a:t> 1300.</a:t>
+            </a:r>
+            <a:endParaRPr lang="de-DE" dirty="0">
+              <a:solidFill>
+                <a:srgbClr val="A5355C"/>
+              </a:solidFill>
+              <a:latin typeface="Lucida Console" panose="020B0609040504020204" pitchFamily="49" charset="0"/>
+            </a:endParaRPr>
+          </a:p>
+        </p:txBody>
+      </p:sp>
+      <p:sp>
+        <p:nvSpPr>
+          <p:cNvPr id="9" name="Rectangle 8">
+            <a:extLst>
+              <a:ext uri="{FF2B5EF4-FFF2-40B4-BE49-F238E27FC236}">
+                <a16:creationId xmlns:a16="http://schemas.microsoft.com/office/drawing/2014/main" id="{C0CB64A0-3CE4-6862-6924-CC5AF4ECAFB8}"/>
+              </a:ext>
+            </a:extLst>
+          </p:cNvPr>
+          <p:cNvSpPr/>
+          <p:nvPr/>
+        </p:nvSpPr>
+        <p:spPr>
+          <a:xfrm>
+            <a:off x="3142725" y="1082490"/>
+            <a:ext cx="6094769" cy="389616"/>
+          </a:xfrm>
+          <a:prstGeom prst="rect">
+            <a:avLst/>
+          </a:prstGeom>
+          <a:solidFill>
+            <a:srgbClr val="FFFFFF"/>
+          </a:solidFill>
+          <a:ln>
+            <a:solidFill>
+              <a:srgbClr val="FFFFFF"/>
+            </a:solidFill>
+          </a:ln>
+        </p:spPr>
+        <p:style>
+          <a:lnRef idx="2">
+            <a:schemeClr val="accent1">
+              <a:shade val="15000"/>
+            </a:schemeClr>
+          </a:lnRef>
+          <a:fillRef idx="1">
+            <a:schemeClr val="accent1"/>
+          </a:fillRef>
+          <a:effectRef idx="0">
+            <a:schemeClr val="accent1"/>
+          </a:effectRef>
+          <a:fontRef idx="minor">
+            <a:schemeClr val="lt1"/>
+          </a:fontRef>
+        </p:style>
+        <p:txBody>
+          <a:bodyPr rtlCol="0" anchor="ctr"/>
+          <a:lstStyle/>
+          <a:p>
+            <a:pPr algn="ctr"/>
+            <a:r>
+              <a:rPr lang="de-DE" dirty="0">
+                <a:solidFill>
+                  <a:srgbClr val="A5355C"/>
+                </a:solidFill>
+                <a:latin typeface="Lucida Console" panose="020B0609040504020204" pitchFamily="49" charset="0"/>
+              </a:rPr>
+              <a:t>This was a GET </a:t>
+            </a:r>
+            <a:r>
+              <a:rPr lang="de-DE" dirty="0" err="1">
+                <a:solidFill>
+                  <a:srgbClr val="A5355C"/>
+                </a:solidFill>
+                <a:latin typeface="Lucida Console" panose="020B0609040504020204" pitchFamily="49" charset="0"/>
+              </a:rPr>
+              <a:t>request</a:t>
+            </a:r>
+            <a:r>
+              <a:rPr lang="de-DE" dirty="0">
+                <a:solidFill>
+                  <a:srgbClr val="A5355C"/>
+                </a:solidFill>
+                <a:latin typeface="Lucida Console" panose="020B0609040504020204" pitchFamily="49" charset="0"/>
+              </a:rPr>
+              <a:t>.</a:t>
+            </a:r>
+          </a:p>
+        </p:txBody>
+      </p:sp>
+      <p:pic>
+        <p:nvPicPr>
+          <p:cNvPr id="11" name="Picture 10">
+            <a:extLst>
+              <a:ext uri="{FF2B5EF4-FFF2-40B4-BE49-F238E27FC236}">
+                <a16:creationId xmlns:a16="http://schemas.microsoft.com/office/drawing/2014/main" id="{15EF8F14-C558-770D-C224-CB53123074BF}"/>
+              </a:ext>
+            </a:extLst>
+          </p:cNvPr>
+          <p:cNvPicPr>
+            <a:picLocks noChangeAspect="1"/>
+          </p:cNvPicPr>
+          <p:nvPr/>
+        </p:nvPicPr>
+        <p:blipFill>
+          <a:blip r:embed="rId3"/>
+          <a:stretch>
+            <a:fillRect/>
+          </a:stretch>
+        </p:blipFill>
+        <p:spPr>
+          <a:xfrm>
+            <a:off x="7159143" y="5048740"/>
+            <a:ext cx="4637107" cy="1492305"/>
+          </a:xfrm>
+          <a:prstGeom prst="rect">
+            <a:avLst/>
+          </a:prstGeom>
+        </p:spPr>
+      </p:pic>
+      <p:pic>
+        <p:nvPicPr>
+          <p:cNvPr id="12" name="Picture 4" descr="Stock-Vektorgrafik „Censor blur effect texture. Skin tone colored pixel  mosaic pattern to hide face, body, text or another unwanted content.  Parental control concept“ | Adobe Stock">
+            <a:extLst>
+              <a:ext uri="{FF2B5EF4-FFF2-40B4-BE49-F238E27FC236}">
+                <a16:creationId xmlns:a16="http://schemas.microsoft.com/office/drawing/2014/main" id="{8CBCAC21-42BD-80C7-9B51-EB3EB25874E4}"/>
+              </a:ext>
+            </a:extLst>
+          </p:cNvPr>
+          <p:cNvPicPr>
+            <a:picLocks noChangeAspect="1" noChangeArrowheads="1"/>
+          </p:cNvPicPr>
+          <p:nvPr/>
+        </p:nvPicPr>
+        <p:blipFill rotWithShape="1">
+          <a:blip r:embed="rId4">
+            <a:alphaModFix amt="70000"/>
+            <a:extLst>
+              <a:ext uri="{28A0092B-C50C-407E-A947-70E740481C1C}">
+                <a14:useLocalDpi xmlns:a14="http://schemas.microsoft.com/office/drawing/2010/main" val="0"/>
+              </a:ext>
+            </a:extLst>
+          </a:blip>
+          <a:srcRect l="14069" t="21339" r="14035" b="20226"/>
+          <a:stretch>
+            <a:fillRect/>
+          </a:stretch>
+        </p:blipFill>
+        <p:spPr bwMode="auto">
+          <a:xfrm>
+            <a:off x="8577812" y="5926209"/>
+            <a:ext cx="2726188" cy="368005"/>
+          </a:xfrm>
+          <a:prstGeom prst="rect">
+            <a:avLst/>
+          </a:prstGeom>
+          <a:noFill/>
+          <a:extLst>
+            <a:ext uri="{909E8E84-426E-40DD-AFC4-6F175D3DCCD1}">
+              <a14:hiddenFill xmlns:a14="http://schemas.microsoft.com/office/drawing/2010/main">
+                <a:solidFill>
+                  <a:srgbClr val="FFFFFF"/>
+                </a:solidFill>
+              </a14:hiddenFill>
+            </a:ext>
+          </a:extLst>
+        </p:spPr>
+      </p:pic>
+      <p:sp>
+        <p:nvSpPr>
+          <p:cNvPr id="13" name="Rectangle 12">
+            <a:extLst>
+              <a:ext uri="{FF2B5EF4-FFF2-40B4-BE49-F238E27FC236}">
+                <a16:creationId xmlns:a16="http://schemas.microsoft.com/office/drawing/2014/main" id="{5E5715BD-A90C-2338-2B3E-283FE914DCA3}"/>
+              </a:ext>
+            </a:extLst>
+          </p:cNvPr>
+          <p:cNvSpPr/>
+          <p:nvPr/>
+        </p:nvSpPr>
+        <p:spPr>
+          <a:xfrm>
+            <a:off x="7382518" y="5920649"/>
+            <a:ext cx="4358827" cy="568563"/>
+          </a:xfrm>
+          <a:prstGeom prst="rect">
+            <a:avLst/>
+          </a:prstGeom>
+          <a:noFill/>
+          <a:ln>
+            <a:solidFill>
+              <a:srgbClr val="A5355C"/>
+            </a:solidFill>
+          </a:ln>
+        </p:spPr>
+        <p:style>
+          <a:lnRef idx="2">
+            <a:schemeClr val="accent1">
+              <a:shade val="15000"/>
+            </a:schemeClr>
+          </a:lnRef>
+          <a:fillRef idx="1">
+            <a:schemeClr val="accent1"/>
+          </a:fillRef>
+          <a:effectRef idx="0">
+            <a:schemeClr val="accent1"/>
+          </a:effectRef>
+          <a:fontRef idx="minor">
+            <a:schemeClr val="lt1"/>
+          </a:fontRef>
+        </p:style>
+        <p:txBody>
+          <a:bodyPr rtlCol="0" anchor="ctr"/>
+          <a:lstStyle/>
+          <a:p>
+            <a:pPr algn="ctr"/>
+            <a:endParaRPr lang="de-DE" dirty="0">
+              <a:solidFill>
+                <a:srgbClr val="A5355C"/>
+              </a:solidFill>
+              <a:latin typeface="Lucida Console" panose="020B0609040504020204" pitchFamily="49" charset="0"/>
+            </a:endParaRPr>
+          </a:p>
+        </p:txBody>
+      </p:sp>
+      <p:sp>
+        <p:nvSpPr>
+          <p:cNvPr id="14" name="Rectangle 13">
+            <a:extLst>
+              <a:ext uri="{FF2B5EF4-FFF2-40B4-BE49-F238E27FC236}">
+                <a16:creationId xmlns:a16="http://schemas.microsoft.com/office/drawing/2014/main" id="{FF945201-B53C-55B8-27AC-9C56A4149EAF}"/>
+              </a:ext>
+            </a:extLst>
+          </p:cNvPr>
+          <p:cNvSpPr/>
+          <p:nvPr/>
+        </p:nvSpPr>
+        <p:spPr>
+          <a:xfrm>
+            <a:off x="7233775" y="3733811"/>
+            <a:ext cx="524600" cy="204280"/>
+          </a:xfrm>
+          <a:prstGeom prst="rect">
+            <a:avLst/>
+          </a:prstGeom>
+          <a:noFill/>
+          <a:ln>
+            <a:solidFill>
+              <a:srgbClr val="A5355C"/>
+            </a:solidFill>
+          </a:ln>
+        </p:spPr>
+        <p:style>
+          <a:lnRef idx="2">
+            <a:schemeClr val="accent1">
+              <a:shade val="15000"/>
+            </a:schemeClr>
+          </a:lnRef>
+          <a:fillRef idx="1">
+            <a:schemeClr val="accent1"/>
+          </a:fillRef>
+          <a:effectRef idx="0">
+            <a:schemeClr val="accent1"/>
+          </a:effectRef>
+          <a:fontRef idx="minor">
+            <a:schemeClr val="lt1"/>
+          </a:fontRef>
+        </p:style>
+        <p:txBody>
+          <a:bodyPr rtlCol="0" anchor="ctr"/>
+          <a:lstStyle/>
+          <a:p>
+            <a:pPr algn="ctr"/>
+            <a:endParaRPr lang="de-DE" dirty="0">
+              <a:solidFill>
+                <a:srgbClr val="A5355C"/>
+              </a:solidFill>
+              <a:latin typeface="Lucida Console" panose="020B0609040504020204" pitchFamily="49" charset="0"/>
+            </a:endParaRPr>
+          </a:p>
+        </p:txBody>
+      </p:sp>
+      <p:sp>
+        <p:nvSpPr>
+          <p:cNvPr id="15" name="Rectangle 14">
+            <a:extLst>
+              <a:ext uri="{FF2B5EF4-FFF2-40B4-BE49-F238E27FC236}">
+                <a16:creationId xmlns:a16="http://schemas.microsoft.com/office/drawing/2014/main" id="{FA11ECE2-32D1-DCEC-6D1E-7B3C65F57FDE}"/>
+              </a:ext>
+            </a:extLst>
+          </p:cNvPr>
+          <p:cNvSpPr/>
+          <p:nvPr/>
+        </p:nvSpPr>
+        <p:spPr>
+          <a:xfrm>
+            <a:off x="7758375" y="4210742"/>
+            <a:ext cx="1267819" cy="204280"/>
+          </a:xfrm>
+          <a:prstGeom prst="rect">
+            <a:avLst/>
+          </a:prstGeom>
+          <a:noFill/>
+          <a:ln>
+            <a:solidFill>
+              <a:srgbClr val="A5355C"/>
+            </a:solidFill>
+          </a:ln>
+        </p:spPr>
+        <p:style>
+          <a:lnRef idx="2">
+            <a:schemeClr val="accent1">
+              <a:shade val="15000"/>
+            </a:schemeClr>
+          </a:lnRef>
+          <a:fillRef idx="1">
+            <a:schemeClr val="accent1"/>
+          </a:fillRef>
+          <a:effectRef idx="0">
+            <a:schemeClr val="accent1"/>
+          </a:effectRef>
+          <a:fontRef idx="minor">
+            <a:schemeClr val="lt1"/>
+          </a:fontRef>
+        </p:style>
+        <p:txBody>
+          <a:bodyPr rtlCol="0" anchor="ctr"/>
+          <a:lstStyle/>
+          <a:p>
+            <a:pPr algn="ctr"/>
+            <a:endParaRPr lang="de-DE" dirty="0">
+              <a:solidFill>
+                <a:srgbClr val="A5355C"/>
+              </a:solidFill>
+              <a:latin typeface="Lucida Console" panose="020B0609040504020204" pitchFamily="49" charset="0"/>
+            </a:endParaRPr>
+          </a:p>
+        </p:txBody>
+      </p:sp>
+      <p:cxnSp>
+        <p:nvCxnSpPr>
+          <p:cNvPr id="16" name="Straight Arrow Connector 15">
+            <a:extLst>
+              <a:ext uri="{FF2B5EF4-FFF2-40B4-BE49-F238E27FC236}">
+                <a16:creationId xmlns:a16="http://schemas.microsoft.com/office/drawing/2014/main" id="{78CE1C54-6B68-0130-2D72-E14F42404535}"/>
+              </a:ext>
+            </a:extLst>
+          </p:cNvPr>
+          <p:cNvCxnSpPr>
+            <a:cxnSpLocks/>
+          </p:cNvCxnSpPr>
+          <p:nvPr/>
+        </p:nvCxnSpPr>
+        <p:spPr>
+          <a:xfrm flipH="1">
+            <a:off x="6614878" y="6187407"/>
+            <a:ext cx="767640" cy="0"/>
+          </a:xfrm>
+          <a:prstGeom prst="straightConnector1">
+            <a:avLst/>
+          </a:prstGeom>
+          <a:ln w="38100" cap="flat" cmpd="sng" algn="ctr">
+            <a:solidFill>
+              <a:srgbClr val="A5355C"/>
+            </a:solidFill>
+            <a:prstDash val="solid"/>
+            <a:round/>
+            <a:headEnd type="none" w="med" len="med"/>
+            <a:tailEnd type="arrow" w="med" len="med"/>
+          </a:ln>
+        </p:spPr>
+        <p:style>
+          <a:lnRef idx="0">
+            <a:scrgbClr r="0" g="0" b="0"/>
+          </a:lnRef>
+          <a:fillRef idx="0">
+            <a:scrgbClr r="0" g="0" b="0"/>
+          </a:fillRef>
+          <a:effectRef idx="0">
+            <a:scrgbClr r="0" g="0" b="0"/>
+          </a:effectRef>
+          <a:fontRef idx="minor">
+            <a:schemeClr val="tx1"/>
+          </a:fontRef>
+        </p:style>
+      </p:cxnSp>
+      <p:cxnSp>
+        <p:nvCxnSpPr>
+          <p:cNvPr id="17" name="Straight Arrow Connector 16">
+            <a:extLst>
+              <a:ext uri="{FF2B5EF4-FFF2-40B4-BE49-F238E27FC236}">
+                <a16:creationId xmlns:a16="http://schemas.microsoft.com/office/drawing/2014/main" id="{C2A5865E-3CD4-65B7-8E26-86DC1BEC8952}"/>
+              </a:ext>
+            </a:extLst>
+          </p:cNvPr>
+          <p:cNvCxnSpPr>
+            <a:cxnSpLocks/>
+          </p:cNvCxnSpPr>
+          <p:nvPr/>
+        </p:nvCxnSpPr>
+        <p:spPr>
+          <a:xfrm flipV="1">
+            <a:off x="7522763" y="1520260"/>
+            <a:ext cx="0" cy="2213551"/>
+          </a:xfrm>
+          <a:prstGeom prst="straightConnector1">
+            <a:avLst/>
+          </a:prstGeom>
+          <a:ln w="38100" cap="flat" cmpd="sng" algn="ctr">
+            <a:solidFill>
+              <a:srgbClr val="A5355C"/>
+            </a:solidFill>
+            <a:prstDash val="solid"/>
+            <a:round/>
+            <a:headEnd type="none" w="med" len="med"/>
+            <a:tailEnd type="arrow" w="med" len="med"/>
+          </a:ln>
+        </p:spPr>
+        <p:style>
+          <a:lnRef idx="0">
+            <a:scrgbClr r="0" g="0" b="0"/>
+          </a:lnRef>
+          <a:fillRef idx="0">
+            <a:scrgbClr r="0" g="0" b="0"/>
+          </a:fillRef>
+          <a:effectRef idx="0">
+            <a:scrgbClr r="0" g="0" b="0"/>
+          </a:effectRef>
+          <a:fontRef idx="minor">
+            <a:schemeClr val="tx1"/>
+          </a:fontRef>
+        </p:style>
+      </p:cxnSp>
+      <p:cxnSp>
+        <p:nvCxnSpPr>
+          <p:cNvPr id="20" name="Straight Arrow Connector 19">
+            <a:extLst>
+              <a:ext uri="{FF2B5EF4-FFF2-40B4-BE49-F238E27FC236}">
+                <a16:creationId xmlns:a16="http://schemas.microsoft.com/office/drawing/2014/main" id="{7FB41D82-FE1D-DD54-7368-41964757AB11}"/>
+              </a:ext>
+            </a:extLst>
+          </p:cNvPr>
+          <p:cNvCxnSpPr>
+            <a:cxnSpLocks/>
+          </p:cNvCxnSpPr>
+          <p:nvPr/>
+        </p:nvCxnSpPr>
+        <p:spPr>
+          <a:xfrm flipV="1">
+            <a:off x="8746638" y="1009767"/>
+            <a:ext cx="0" cy="3200975"/>
+          </a:xfrm>
+          <a:prstGeom prst="straightConnector1">
+            <a:avLst/>
+          </a:prstGeom>
+          <a:ln w="38100" cap="flat" cmpd="sng" algn="ctr">
+            <a:solidFill>
+              <a:srgbClr val="A5355C"/>
+            </a:solidFill>
+            <a:prstDash val="solid"/>
+            <a:round/>
+            <a:headEnd type="none" w="med" len="med"/>
+            <a:tailEnd type="arrow" w="med" len="med"/>
+          </a:ln>
+        </p:spPr>
+        <p:style>
+          <a:lnRef idx="0">
+            <a:scrgbClr r="0" g="0" b="0"/>
+          </a:lnRef>
+          <a:fillRef idx="0">
+            <a:scrgbClr r="0" g="0" b="0"/>
+          </a:fillRef>
+          <a:effectRef idx="0">
+            <a:scrgbClr r="0" g="0" b="0"/>
+          </a:effectRef>
+          <a:fontRef idx="minor">
+            <a:schemeClr val="tx1"/>
+          </a:fontRef>
+        </p:style>
+      </p:cxnSp>
+      <p:sp>
+        <p:nvSpPr>
+          <p:cNvPr id="22" name="Rectangle 21">
+            <a:extLst>
+              <a:ext uri="{FF2B5EF4-FFF2-40B4-BE49-F238E27FC236}">
+                <a16:creationId xmlns:a16="http://schemas.microsoft.com/office/drawing/2014/main" id="{28CA26A6-5F4C-2276-3174-B9C302746920}"/>
+              </a:ext>
+            </a:extLst>
+          </p:cNvPr>
+          <p:cNvSpPr/>
+          <p:nvPr/>
+        </p:nvSpPr>
+        <p:spPr>
+          <a:xfrm>
+            <a:off x="2772198" y="2786785"/>
+            <a:ext cx="1221992" cy="231295"/>
+          </a:xfrm>
+          <a:prstGeom prst="rect">
+            <a:avLst/>
+          </a:prstGeom>
+          <a:noFill/>
+          <a:ln>
+            <a:solidFill>
+              <a:srgbClr val="A5355C"/>
+            </a:solidFill>
+          </a:ln>
+        </p:spPr>
+        <p:style>
+          <a:lnRef idx="2">
+            <a:schemeClr val="accent1">
+              <a:shade val="15000"/>
+            </a:schemeClr>
+          </a:lnRef>
+          <a:fillRef idx="1">
+            <a:schemeClr val="accent1"/>
+          </a:fillRef>
+          <a:effectRef idx="0">
+            <a:schemeClr val="accent1"/>
+          </a:effectRef>
+          <a:fontRef idx="minor">
+            <a:schemeClr val="lt1"/>
+          </a:fontRef>
+        </p:style>
+        <p:txBody>
+          <a:bodyPr rtlCol="0" anchor="ctr"/>
+          <a:lstStyle/>
+          <a:p>
+            <a:pPr algn="ctr"/>
+            <a:endParaRPr lang="de-DE" dirty="0">
+              <a:solidFill>
+                <a:srgbClr val="A5355C"/>
+              </a:solidFill>
+              <a:latin typeface="Lucida Console" panose="020B0609040504020204" pitchFamily="49" charset="0"/>
+            </a:endParaRPr>
+          </a:p>
+        </p:txBody>
+      </p:sp>
+      <p:sp>
+        <p:nvSpPr>
+          <p:cNvPr id="23" name="Rectangle 22">
+            <a:extLst>
+              <a:ext uri="{FF2B5EF4-FFF2-40B4-BE49-F238E27FC236}">
+                <a16:creationId xmlns:a16="http://schemas.microsoft.com/office/drawing/2014/main" id="{60D7872B-C566-8826-8E4E-9D145B1C23A1}"/>
+              </a:ext>
+            </a:extLst>
+          </p:cNvPr>
+          <p:cNvSpPr/>
+          <p:nvPr/>
+        </p:nvSpPr>
+        <p:spPr>
+          <a:xfrm>
+            <a:off x="4100468" y="6049303"/>
+            <a:ext cx="2333815" cy="311253"/>
+          </a:xfrm>
+          <a:prstGeom prst="rect">
+            <a:avLst/>
+          </a:prstGeom>
+          <a:solidFill>
+            <a:srgbClr val="FFFFFF"/>
+          </a:solidFill>
+          <a:ln>
+            <a:solidFill>
+              <a:srgbClr val="A5355C"/>
+            </a:solidFill>
+          </a:ln>
+        </p:spPr>
+        <p:style>
+          <a:lnRef idx="2">
+            <a:schemeClr val="accent1">
+              <a:shade val="15000"/>
+            </a:schemeClr>
+          </a:lnRef>
+          <a:fillRef idx="1">
+            <a:schemeClr val="accent1"/>
+          </a:fillRef>
+          <a:effectRef idx="0">
+            <a:schemeClr val="accent1"/>
+          </a:effectRef>
+          <a:fontRef idx="minor">
+            <a:schemeClr val="lt1"/>
+          </a:fontRef>
+        </p:style>
+        <p:txBody>
+          <a:bodyPr rtlCol="0" anchor="ctr"/>
+          <a:lstStyle/>
+          <a:p>
+            <a:pPr algn="ctr"/>
+            <a:r>
+              <a:rPr lang="de-DE" dirty="0" err="1">
+                <a:solidFill>
+                  <a:srgbClr val="A5355C"/>
+                </a:solidFill>
+                <a:latin typeface="Lucida Console" panose="020B0609040504020204" pitchFamily="49" charset="0"/>
+              </a:rPr>
+              <a:t>Authorization</a:t>
+            </a:r>
+            <a:endParaRPr lang="de-DE" dirty="0">
+              <a:solidFill>
+                <a:srgbClr val="A5355C"/>
+              </a:solidFill>
+              <a:latin typeface="Lucida Console" panose="020B0609040504020204" pitchFamily="49" charset="0"/>
+            </a:endParaRPr>
+          </a:p>
+        </p:txBody>
+      </p:sp>
+      <p:sp>
+        <p:nvSpPr>
+          <p:cNvPr id="24" name="Rectangle 23">
+            <a:extLst>
+              <a:ext uri="{FF2B5EF4-FFF2-40B4-BE49-F238E27FC236}">
+                <a16:creationId xmlns:a16="http://schemas.microsoft.com/office/drawing/2014/main" id="{297D6DDA-AC70-20C2-DA1F-9D0A049FFC3D}"/>
+              </a:ext>
+            </a:extLst>
+          </p:cNvPr>
+          <p:cNvSpPr/>
+          <p:nvPr/>
+        </p:nvSpPr>
+        <p:spPr>
+          <a:xfrm>
+            <a:off x="701944" y="5608645"/>
+            <a:ext cx="6094769" cy="389616"/>
+          </a:xfrm>
+          <a:prstGeom prst="rect">
+            <a:avLst/>
+          </a:prstGeom>
+          <a:solidFill>
+            <a:srgbClr val="FFFFFF"/>
+          </a:solidFill>
+          <a:ln>
+            <a:solidFill>
+              <a:srgbClr val="FFFFFF"/>
+            </a:solidFill>
+          </a:ln>
+        </p:spPr>
+        <p:style>
+          <a:lnRef idx="2">
+            <a:schemeClr val="accent1">
+              <a:shade val="15000"/>
+            </a:schemeClr>
+          </a:lnRef>
+          <a:fillRef idx="1">
+            <a:schemeClr val="accent1"/>
+          </a:fillRef>
+          <a:effectRef idx="0">
+            <a:schemeClr val="accent1"/>
+          </a:effectRef>
+          <a:fontRef idx="minor">
+            <a:schemeClr val="lt1"/>
+          </a:fontRef>
+        </p:style>
+        <p:txBody>
+          <a:bodyPr rtlCol="0" anchor="ctr"/>
+          <a:lstStyle/>
+          <a:p>
+            <a:pPr algn="ctr"/>
+            <a:r>
+              <a:rPr lang="de-DE" dirty="0">
+                <a:solidFill>
+                  <a:srgbClr val="A5355C"/>
+                </a:solidFill>
+                <a:latin typeface="Lucida Console" panose="020B0609040504020204" pitchFamily="49" charset="0"/>
+              </a:rPr>
+              <a:t>This </a:t>
+            </a:r>
+            <a:r>
+              <a:rPr lang="de-DE" dirty="0" err="1">
+                <a:solidFill>
+                  <a:srgbClr val="A5355C"/>
+                </a:solidFill>
+                <a:latin typeface="Lucida Console" panose="020B0609040504020204" pitchFamily="49" charset="0"/>
+              </a:rPr>
+              <a:t>is</a:t>
+            </a:r>
+            <a:r>
+              <a:rPr lang="de-DE" dirty="0">
+                <a:solidFill>
+                  <a:srgbClr val="A5355C"/>
+                </a:solidFill>
+                <a:latin typeface="Lucida Console" panose="020B0609040504020204" pitchFamily="49" charset="0"/>
+              </a:rPr>
+              <a:t> </a:t>
+            </a:r>
+            <a:r>
+              <a:rPr lang="de-DE" dirty="0" err="1">
+                <a:solidFill>
+                  <a:srgbClr val="A5355C"/>
+                </a:solidFill>
+                <a:latin typeface="Lucida Console" panose="020B0609040504020204" pitchFamily="49" charset="0"/>
+              </a:rPr>
+              <a:t>the</a:t>
+            </a:r>
+            <a:r>
+              <a:rPr lang="de-DE" dirty="0">
+                <a:solidFill>
+                  <a:srgbClr val="A5355C"/>
+                </a:solidFill>
+                <a:latin typeface="Lucida Console" panose="020B0609040504020204" pitchFamily="49" charset="0"/>
+              </a:rPr>
+              <a:t> </a:t>
+            </a:r>
+            <a:r>
+              <a:rPr lang="de-DE" b="1" dirty="0" err="1">
+                <a:solidFill>
+                  <a:srgbClr val="A5355C"/>
+                </a:solidFill>
+                <a:latin typeface="Lucida Console" panose="020B0609040504020204" pitchFamily="49" charset="0"/>
+              </a:rPr>
+              <a:t>access</a:t>
+            </a:r>
+            <a:r>
+              <a:rPr lang="de-DE" b="1" dirty="0">
+                <a:solidFill>
+                  <a:srgbClr val="A5355C"/>
+                </a:solidFill>
+                <a:latin typeface="Lucida Console" panose="020B0609040504020204" pitchFamily="49" charset="0"/>
+              </a:rPr>
+              <a:t> </a:t>
+            </a:r>
+            <a:r>
+              <a:rPr lang="de-DE" b="1" dirty="0" err="1">
+                <a:solidFill>
+                  <a:srgbClr val="A5355C"/>
+                </a:solidFill>
+                <a:latin typeface="Lucida Console" panose="020B0609040504020204" pitchFamily="49" charset="0"/>
+              </a:rPr>
+              <a:t>token</a:t>
+            </a:r>
+            <a:r>
+              <a:rPr lang="de-DE" b="1" dirty="0">
+                <a:solidFill>
+                  <a:srgbClr val="A5355C"/>
+                </a:solidFill>
+                <a:latin typeface="Lucida Console" panose="020B0609040504020204" pitchFamily="49" charset="0"/>
+              </a:rPr>
+              <a:t> </a:t>
+            </a:r>
+            <a:r>
+              <a:rPr lang="de-DE" dirty="0" err="1">
+                <a:solidFill>
+                  <a:srgbClr val="A5355C"/>
+                </a:solidFill>
+                <a:latin typeface="Lucida Console" panose="020B0609040504020204" pitchFamily="49" charset="0"/>
+              </a:rPr>
+              <a:t>of</a:t>
+            </a:r>
+            <a:r>
+              <a:rPr lang="de-DE" dirty="0">
+                <a:solidFill>
+                  <a:srgbClr val="A5355C"/>
+                </a:solidFill>
+                <a:latin typeface="Lucida Console" panose="020B0609040504020204" pitchFamily="49" charset="0"/>
+              </a:rPr>
+              <a:t> </a:t>
+            </a:r>
+            <a:r>
+              <a:rPr lang="de-DE" dirty="0" err="1">
+                <a:solidFill>
+                  <a:srgbClr val="A5355C"/>
+                </a:solidFill>
+                <a:latin typeface="Lucida Console" panose="020B0609040504020204" pitchFamily="49" charset="0"/>
+              </a:rPr>
+              <a:t>the</a:t>
+            </a:r>
+            <a:r>
+              <a:rPr lang="de-DE" dirty="0">
+                <a:solidFill>
+                  <a:srgbClr val="A5355C"/>
+                </a:solidFill>
+                <a:latin typeface="Lucida Console" panose="020B0609040504020204" pitchFamily="49" charset="0"/>
+              </a:rPr>
+              <a:t> </a:t>
+            </a:r>
+            <a:r>
+              <a:rPr lang="de-DE" dirty="0" err="1">
+                <a:solidFill>
+                  <a:srgbClr val="A5355C"/>
+                </a:solidFill>
+                <a:latin typeface="Lucida Console" panose="020B0609040504020204" pitchFamily="49" charset="0"/>
+              </a:rPr>
+              <a:t>session</a:t>
+            </a:r>
+            <a:r>
+              <a:rPr lang="de-DE" dirty="0">
+                <a:solidFill>
+                  <a:srgbClr val="A5355C"/>
+                </a:solidFill>
+                <a:latin typeface="Lucida Console" panose="020B0609040504020204" pitchFamily="49" charset="0"/>
+              </a:rPr>
+              <a:t>.</a:t>
+            </a:r>
+          </a:p>
+        </p:txBody>
+      </p:sp>
+    </p:spTree>
+    <p:extLst>
+      <p:ext uri="{BB962C8B-B14F-4D97-AF65-F5344CB8AC3E}">
+        <p14:creationId xmlns:p14="http://schemas.microsoft.com/office/powerpoint/2010/main" val="810924478"/>
       </p:ext>
     </p:extLst>
   </p:cSld>

</xml_diff>

<commit_message>
Document httr2 metadata extraction
</commit_message>
<xml_diff>
--- a/vignettes/images/images.pptx
+++ b/vignettes/images/images.pptx
@@ -5,7 +5,7 @@
     <p:sldMasterId id="2147483648" r:id="rId1"/>
   </p:sldMasterIdLst>
   <p:notesMasterIdLst>
-    <p:notesMasterId r:id="rId9"/>
+    <p:notesMasterId r:id="rId11"/>
   </p:notesMasterIdLst>
   <p:sldIdLst>
     <p:sldId id="257" r:id="rId2"/>
@@ -15,6 +15,8 @@
     <p:sldId id="262" r:id="rId6"/>
     <p:sldId id="264" r:id="rId7"/>
     <p:sldId id="265" r:id="rId8"/>
+    <p:sldId id="266" r:id="rId9"/>
+    <p:sldId id="267" r:id="rId10"/>
   </p:sldIdLst>
   <p:sldSz cx="12192000" cy="6858000"/>
   <p:notesSz cx="6858000" cy="9144000"/>
@@ -203,7 +205,7 @@
           <a:p>
             <a:fld id="{47B53907-AE11-4DB4-A650-AEF08113A763}" type="datetimeFigureOut">
               <a:rPr lang="de-DE" smtClean="0"/>
-              <a:t>22.06.2026</a:t>
+              <a:t>23.06.2026</a:t>
             </a:fld>
             <a:endParaRPr lang="de-DE"/>
           </a:p>
@@ -812,7 +814,7 @@
           <a:p>
             <a:fld id="{0C105CC3-179F-4A2D-9012-371B48952F93}" type="datetimeFigureOut">
               <a:rPr lang="de-DE" smtClean="0"/>
-              <a:t>22.06.2026</a:t>
+              <a:t>23.06.2026</a:t>
             </a:fld>
             <a:endParaRPr lang="de-DE" dirty="0"/>
           </a:p>
@@ -1012,7 +1014,7 @@
           <a:p>
             <a:fld id="{0C105CC3-179F-4A2D-9012-371B48952F93}" type="datetimeFigureOut">
               <a:rPr lang="de-DE" smtClean="0"/>
-              <a:t>22.06.2026</a:t>
+              <a:t>23.06.2026</a:t>
             </a:fld>
             <a:endParaRPr lang="de-DE" dirty="0"/>
           </a:p>
@@ -1222,7 +1224,7 @@
           <a:p>
             <a:fld id="{0C105CC3-179F-4A2D-9012-371B48952F93}" type="datetimeFigureOut">
               <a:rPr lang="de-DE" smtClean="0"/>
-              <a:t>22.06.2026</a:t>
+              <a:t>23.06.2026</a:t>
             </a:fld>
             <a:endParaRPr lang="de-DE" dirty="0"/>
           </a:p>
@@ -1422,7 +1424,7 @@
           <a:p>
             <a:fld id="{0C105CC3-179F-4A2D-9012-371B48952F93}" type="datetimeFigureOut">
               <a:rPr lang="de-DE" smtClean="0"/>
-              <a:t>22.06.2026</a:t>
+              <a:t>23.06.2026</a:t>
             </a:fld>
             <a:endParaRPr lang="de-DE" dirty="0"/>
           </a:p>
@@ -1698,7 +1700,7 @@
           <a:p>
             <a:fld id="{0C105CC3-179F-4A2D-9012-371B48952F93}" type="datetimeFigureOut">
               <a:rPr lang="de-DE" smtClean="0"/>
-              <a:t>22.06.2026</a:t>
+              <a:t>23.06.2026</a:t>
             </a:fld>
             <a:endParaRPr lang="de-DE" dirty="0"/>
           </a:p>
@@ -1966,7 +1968,7 @@
           <a:p>
             <a:fld id="{0C105CC3-179F-4A2D-9012-371B48952F93}" type="datetimeFigureOut">
               <a:rPr lang="de-DE" smtClean="0"/>
-              <a:t>22.06.2026</a:t>
+              <a:t>23.06.2026</a:t>
             </a:fld>
             <a:endParaRPr lang="de-DE" dirty="0"/>
           </a:p>
@@ -2381,7 +2383,7 @@
           <a:p>
             <a:fld id="{0C105CC3-179F-4A2D-9012-371B48952F93}" type="datetimeFigureOut">
               <a:rPr lang="de-DE" smtClean="0"/>
-              <a:t>22.06.2026</a:t>
+              <a:t>23.06.2026</a:t>
             </a:fld>
             <a:endParaRPr lang="de-DE" dirty="0"/>
           </a:p>
@@ -2523,7 +2525,7 @@
           <a:p>
             <a:fld id="{0C105CC3-179F-4A2D-9012-371B48952F93}" type="datetimeFigureOut">
               <a:rPr lang="de-DE" smtClean="0"/>
-              <a:t>22.06.2026</a:t>
+              <a:t>23.06.2026</a:t>
             </a:fld>
             <a:endParaRPr lang="de-DE" dirty="0"/>
           </a:p>
@@ -2636,7 +2638,7 @@
           <a:p>
             <a:fld id="{0C105CC3-179F-4A2D-9012-371B48952F93}" type="datetimeFigureOut">
               <a:rPr lang="de-DE" smtClean="0"/>
-              <a:t>22.06.2026</a:t>
+              <a:t>23.06.2026</a:t>
             </a:fld>
             <a:endParaRPr lang="de-DE" dirty="0"/>
           </a:p>
@@ -2949,7 +2951,7 @@
           <a:p>
             <a:fld id="{0C105CC3-179F-4A2D-9012-371B48952F93}" type="datetimeFigureOut">
               <a:rPr lang="de-DE" smtClean="0"/>
-              <a:t>22.06.2026</a:t>
+              <a:t>23.06.2026</a:t>
             </a:fld>
             <a:endParaRPr lang="de-DE" dirty="0"/>
           </a:p>
@@ -3238,7 +3240,7 @@
           <a:p>
             <a:fld id="{0C105CC3-179F-4A2D-9012-371B48952F93}" type="datetimeFigureOut">
               <a:rPr lang="de-DE" smtClean="0"/>
-              <a:t>22.06.2026</a:t>
+              <a:t>23.06.2026</a:t>
             </a:fld>
             <a:endParaRPr lang="de-DE" dirty="0"/>
           </a:p>
@@ -3481,7 +3483,7 @@
           <a:p>
             <a:fld id="{0C105CC3-179F-4A2D-9012-371B48952F93}" type="datetimeFigureOut">
               <a:rPr lang="de-DE" smtClean="0"/>
-              <a:t>22.06.2026</a:t>
+              <a:t>23.06.2026</a:t>
             </a:fld>
             <a:endParaRPr lang="de-DE" dirty="0"/>
           </a:p>
@@ -9089,6 +9091,926 @@
     <p:extLst>
       <p:ext uri="{BB962C8B-B14F-4D97-AF65-F5344CB8AC3E}">
         <p14:creationId xmlns:p14="http://schemas.microsoft.com/office/powerpoint/2010/main" val="810924478"/>
+      </p:ext>
+    </p:extLst>
+  </p:cSld>
+  <p:clrMapOvr>
+    <a:masterClrMapping/>
+  </p:clrMapOvr>
+</p:sld>
+</file>
+
+<file path=ppt/slides/slide8.xml><?xml version="1.0" encoding="utf-8"?>
+<p:sld xmlns:a="http://schemas.openxmlformats.org/drawingml/2006/main" xmlns:r="http://schemas.openxmlformats.org/officeDocument/2006/relationships" xmlns:p="http://schemas.openxmlformats.org/presentationml/2006/main">
+  <p:cSld>
+    <p:spTree>
+      <p:nvGrpSpPr>
+        <p:cNvPr id="1" name=""/>
+        <p:cNvGrpSpPr/>
+        <p:nvPr/>
+      </p:nvGrpSpPr>
+      <p:grpSpPr>
+        <a:xfrm>
+          <a:off x="0" y="0"/>
+          <a:ext cx="0" cy="0"/>
+          <a:chOff x="0" y="0"/>
+          <a:chExt cx="0" cy="0"/>
+        </a:xfrm>
+      </p:grpSpPr>
+      <p:pic>
+        <p:nvPicPr>
+          <p:cNvPr id="5" name="Picture 4">
+            <a:extLst>
+              <a:ext uri="{FF2B5EF4-FFF2-40B4-BE49-F238E27FC236}">
+                <a16:creationId xmlns:a16="http://schemas.microsoft.com/office/drawing/2014/main" id="{52767504-0765-E71F-E292-EFB01F5FB946}"/>
+              </a:ext>
+            </a:extLst>
+          </p:cNvPr>
+          <p:cNvPicPr>
+            <a:picLocks noChangeAspect="1"/>
+          </p:cNvPicPr>
+          <p:nvPr/>
+        </p:nvPicPr>
+        <p:blipFill>
+          <a:blip r:embed="rId2"/>
+          <a:srcRect r="22783"/>
+          <a:stretch>
+            <a:fillRect/>
+          </a:stretch>
+        </p:blipFill>
+        <p:spPr>
+          <a:xfrm>
+            <a:off x="4778930" y="1015475"/>
+            <a:ext cx="3105356" cy="3999700"/>
+          </a:xfrm>
+          <a:prstGeom prst="rect">
+            <a:avLst/>
+          </a:prstGeom>
+        </p:spPr>
+      </p:pic>
+      <p:pic>
+        <p:nvPicPr>
+          <p:cNvPr id="7" name="Picture 6">
+            <a:extLst>
+              <a:ext uri="{FF2B5EF4-FFF2-40B4-BE49-F238E27FC236}">
+                <a16:creationId xmlns:a16="http://schemas.microsoft.com/office/drawing/2014/main" id="{87E2F94F-1E97-AB42-6663-218B39767794}"/>
+              </a:ext>
+            </a:extLst>
+          </p:cNvPr>
+          <p:cNvPicPr>
+            <a:picLocks noChangeAspect="1"/>
+          </p:cNvPicPr>
+          <p:nvPr/>
+        </p:nvPicPr>
+        <p:blipFill>
+          <a:blip r:embed="rId3"/>
+          <a:srcRect r="24343"/>
+          <a:stretch>
+            <a:fillRect/>
+          </a:stretch>
+        </p:blipFill>
+        <p:spPr>
+          <a:xfrm>
+            <a:off x="8584683" y="1015475"/>
+            <a:ext cx="2999586" cy="3573354"/>
+          </a:xfrm>
+          <a:prstGeom prst="rect">
+            <a:avLst/>
+          </a:prstGeom>
+        </p:spPr>
+      </p:pic>
+      <p:sp>
+        <p:nvSpPr>
+          <p:cNvPr id="8" name="Rectangle 7">
+            <a:extLst>
+              <a:ext uri="{FF2B5EF4-FFF2-40B4-BE49-F238E27FC236}">
+                <a16:creationId xmlns:a16="http://schemas.microsoft.com/office/drawing/2014/main" id="{A1705856-488A-EA00-71A3-622631411574}"/>
+              </a:ext>
+            </a:extLst>
+          </p:cNvPr>
+          <p:cNvSpPr/>
+          <p:nvPr/>
+        </p:nvSpPr>
+        <p:spPr>
+          <a:xfrm>
+            <a:off x="5367333" y="590878"/>
+            <a:ext cx="1928549" cy="389616"/>
+          </a:xfrm>
+          <a:prstGeom prst="rect">
+            <a:avLst/>
+          </a:prstGeom>
+          <a:solidFill>
+            <a:srgbClr val="FFFFFF"/>
+          </a:solidFill>
+          <a:ln>
+            <a:solidFill>
+              <a:srgbClr val="FFFFFF"/>
+            </a:solidFill>
+          </a:ln>
+        </p:spPr>
+        <p:style>
+          <a:lnRef idx="2">
+            <a:schemeClr val="accent1">
+              <a:shade val="15000"/>
+            </a:schemeClr>
+          </a:lnRef>
+          <a:fillRef idx="1">
+            <a:schemeClr val="accent1"/>
+          </a:fillRef>
+          <a:effectRef idx="0">
+            <a:schemeClr val="accent1"/>
+          </a:effectRef>
+          <a:fontRef idx="minor">
+            <a:schemeClr val="lt1"/>
+          </a:fontRef>
+        </p:style>
+        <p:txBody>
+          <a:bodyPr rtlCol="0" anchor="ctr"/>
+          <a:lstStyle/>
+          <a:p>
+            <a:pPr algn="ctr"/>
+            <a:r>
+              <a:rPr lang="de-DE" dirty="0">
+                <a:solidFill>
+                  <a:srgbClr val="A5355C"/>
+                </a:solidFill>
+                <a:latin typeface="Lucida Console" panose="020B0609040504020204" pitchFamily="49" charset="0"/>
+              </a:rPr>
+              <a:t>Request:</a:t>
+            </a:r>
+          </a:p>
+        </p:txBody>
+      </p:sp>
+      <p:sp>
+        <p:nvSpPr>
+          <p:cNvPr id="9" name="Rectangle 8">
+            <a:extLst>
+              <a:ext uri="{FF2B5EF4-FFF2-40B4-BE49-F238E27FC236}">
+                <a16:creationId xmlns:a16="http://schemas.microsoft.com/office/drawing/2014/main" id="{E706A8FA-EBEC-D7CF-DE2C-307D46CCAC12}"/>
+              </a:ext>
+            </a:extLst>
+          </p:cNvPr>
+          <p:cNvSpPr/>
+          <p:nvPr/>
+        </p:nvSpPr>
+        <p:spPr>
+          <a:xfrm>
+            <a:off x="9331287" y="598369"/>
+            <a:ext cx="1928550" cy="389616"/>
+          </a:xfrm>
+          <a:prstGeom prst="rect">
+            <a:avLst/>
+          </a:prstGeom>
+          <a:solidFill>
+            <a:srgbClr val="FFFFFF"/>
+          </a:solidFill>
+          <a:ln>
+            <a:solidFill>
+              <a:srgbClr val="FFFFFF"/>
+            </a:solidFill>
+          </a:ln>
+        </p:spPr>
+        <p:style>
+          <a:lnRef idx="2">
+            <a:schemeClr val="accent1">
+              <a:shade val="15000"/>
+            </a:schemeClr>
+          </a:lnRef>
+          <a:fillRef idx="1">
+            <a:schemeClr val="accent1"/>
+          </a:fillRef>
+          <a:effectRef idx="0">
+            <a:schemeClr val="accent1"/>
+          </a:effectRef>
+          <a:fontRef idx="minor">
+            <a:schemeClr val="lt1"/>
+          </a:fontRef>
+        </p:style>
+        <p:txBody>
+          <a:bodyPr rtlCol="0" anchor="ctr"/>
+          <a:lstStyle/>
+          <a:p>
+            <a:pPr algn="ctr"/>
+            <a:r>
+              <a:rPr lang="de-DE" dirty="0" err="1">
+                <a:solidFill>
+                  <a:srgbClr val="A5355C"/>
+                </a:solidFill>
+                <a:latin typeface="Lucida Console" panose="020B0609040504020204" pitchFamily="49" charset="0"/>
+              </a:rPr>
+              <a:t>Result</a:t>
+            </a:r>
+            <a:r>
+              <a:rPr lang="de-DE" dirty="0">
+                <a:solidFill>
+                  <a:srgbClr val="A5355C"/>
+                </a:solidFill>
+                <a:latin typeface="Lucida Console" panose="020B0609040504020204" pitchFamily="49" charset="0"/>
+              </a:rPr>
+              <a:t>:</a:t>
+            </a:r>
+          </a:p>
+        </p:txBody>
+      </p:sp>
+      <p:pic>
+        <p:nvPicPr>
+          <p:cNvPr id="11" name="Picture 10">
+            <a:extLst>
+              <a:ext uri="{FF2B5EF4-FFF2-40B4-BE49-F238E27FC236}">
+                <a16:creationId xmlns:a16="http://schemas.microsoft.com/office/drawing/2014/main" id="{CF49A7B7-4219-2B22-59C0-352FE6141AD7}"/>
+              </a:ext>
+            </a:extLst>
+          </p:cNvPr>
+          <p:cNvPicPr>
+            <a:picLocks noChangeAspect="1"/>
+          </p:cNvPicPr>
+          <p:nvPr/>
+        </p:nvPicPr>
+        <p:blipFill>
+          <a:blip r:embed="rId4"/>
+          <a:stretch>
+            <a:fillRect/>
+          </a:stretch>
+        </p:blipFill>
+        <p:spPr>
+          <a:xfrm>
+            <a:off x="627890" y="1015475"/>
+            <a:ext cx="3662783" cy="2867543"/>
+          </a:xfrm>
+          <a:prstGeom prst="rect">
+            <a:avLst/>
+          </a:prstGeom>
+        </p:spPr>
+      </p:pic>
+      <p:sp>
+        <p:nvSpPr>
+          <p:cNvPr id="12" name="Rectangle 11">
+            <a:extLst>
+              <a:ext uri="{FF2B5EF4-FFF2-40B4-BE49-F238E27FC236}">
+                <a16:creationId xmlns:a16="http://schemas.microsoft.com/office/drawing/2014/main" id="{FAA732B1-49AE-6D2E-7B9A-EC5E5B251849}"/>
+              </a:ext>
+            </a:extLst>
+          </p:cNvPr>
+          <p:cNvSpPr/>
+          <p:nvPr/>
+        </p:nvSpPr>
+        <p:spPr>
+          <a:xfrm>
+            <a:off x="1495006" y="598369"/>
+            <a:ext cx="1928549" cy="389616"/>
+          </a:xfrm>
+          <a:prstGeom prst="rect">
+            <a:avLst/>
+          </a:prstGeom>
+          <a:solidFill>
+            <a:srgbClr val="FFFFFF"/>
+          </a:solidFill>
+          <a:ln>
+            <a:solidFill>
+              <a:srgbClr val="FFFFFF"/>
+            </a:solidFill>
+          </a:ln>
+        </p:spPr>
+        <p:style>
+          <a:lnRef idx="2">
+            <a:schemeClr val="accent1">
+              <a:shade val="15000"/>
+            </a:schemeClr>
+          </a:lnRef>
+          <a:fillRef idx="1">
+            <a:schemeClr val="accent1"/>
+          </a:fillRef>
+          <a:effectRef idx="0">
+            <a:schemeClr val="accent1"/>
+          </a:effectRef>
+          <a:fontRef idx="minor">
+            <a:schemeClr val="lt1"/>
+          </a:fontRef>
+        </p:style>
+        <p:txBody>
+          <a:bodyPr rtlCol="0" anchor="ctr"/>
+          <a:lstStyle/>
+          <a:p>
+            <a:pPr algn="ctr"/>
+            <a:r>
+              <a:rPr lang="de-DE" dirty="0">
+                <a:solidFill>
+                  <a:srgbClr val="A5355C"/>
+                </a:solidFill>
+                <a:latin typeface="Lucida Console" panose="020B0609040504020204" pitchFamily="49" charset="0"/>
+              </a:rPr>
+              <a:t>IQB-Studio:</a:t>
+            </a:r>
+          </a:p>
+        </p:txBody>
+      </p:sp>
+      <p:sp>
+        <p:nvSpPr>
+          <p:cNvPr id="13" name="Rectangle 12">
+            <a:extLst>
+              <a:ext uri="{FF2B5EF4-FFF2-40B4-BE49-F238E27FC236}">
+                <a16:creationId xmlns:a16="http://schemas.microsoft.com/office/drawing/2014/main" id="{98C57AB3-D7EF-D893-5684-36F277DAAA2C}"/>
+              </a:ext>
+            </a:extLst>
+          </p:cNvPr>
+          <p:cNvSpPr/>
+          <p:nvPr/>
+        </p:nvSpPr>
+        <p:spPr>
+          <a:xfrm>
+            <a:off x="4784539" y="1428274"/>
+            <a:ext cx="3013104" cy="204182"/>
+          </a:xfrm>
+          <a:prstGeom prst="rect">
+            <a:avLst/>
+          </a:prstGeom>
+          <a:noFill/>
+          <a:ln>
+            <a:solidFill>
+              <a:srgbClr val="A5355C"/>
+            </a:solidFill>
+          </a:ln>
+        </p:spPr>
+        <p:style>
+          <a:lnRef idx="2">
+            <a:schemeClr val="accent1">
+              <a:shade val="15000"/>
+            </a:schemeClr>
+          </a:lnRef>
+          <a:fillRef idx="1">
+            <a:schemeClr val="accent1"/>
+          </a:fillRef>
+          <a:effectRef idx="0">
+            <a:schemeClr val="accent1"/>
+          </a:effectRef>
+          <a:fontRef idx="minor">
+            <a:schemeClr val="lt1"/>
+          </a:fontRef>
+        </p:style>
+        <p:txBody>
+          <a:bodyPr rtlCol="0" anchor="ctr"/>
+          <a:lstStyle/>
+          <a:p>
+            <a:pPr algn="ctr"/>
+            <a:endParaRPr lang="de-DE" dirty="0">
+              <a:solidFill>
+                <a:srgbClr val="A5355C"/>
+              </a:solidFill>
+              <a:latin typeface="Lucida Console" panose="020B0609040504020204" pitchFamily="49" charset="0"/>
+            </a:endParaRPr>
+          </a:p>
+        </p:txBody>
+      </p:sp>
+      <p:sp>
+        <p:nvSpPr>
+          <p:cNvPr id="14" name="Rectangle 13">
+            <a:extLst>
+              <a:ext uri="{FF2B5EF4-FFF2-40B4-BE49-F238E27FC236}">
+                <a16:creationId xmlns:a16="http://schemas.microsoft.com/office/drawing/2014/main" id="{A8FDFFBC-C785-D20D-86D4-0AC845EF9DC3}"/>
+              </a:ext>
+            </a:extLst>
+          </p:cNvPr>
+          <p:cNvSpPr/>
+          <p:nvPr/>
+        </p:nvSpPr>
+        <p:spPr>
+          <a:xfrm>
+            <a:off x="10237914" y="1015475"/>
+            <a:ext cx="504884" cy="224294"/>
+          </a:xfrm>
+          <a:prstGeom prst="rect">
+            <a:avLst/>
+          </a:prstGeom>
+          <a:noFill/>
+          <a:ln>
+            <a:solidFill>
+              <a:srgbClr val="A5355C"/>
+            </a:solidFill>
+          </a:ln>
+        </p:spPr>
+        <p:style>
+          <a:lnRef idx="2">
+            <a:schemeClr val="accent1">
+              <a:shade val="15000"/>
+            </a:schemeClr>
+          </a:lnRef>
+          <a:fillRef idx="1">
+            <a:schemeClr val="accent1"/>
+          </a:fillRef>
+          <a:effectRef idx="0">
+            <a:schemeClr val="accent1"/>
+          </a:effectRef>
+          <a:fontRef idx="minor">
+            <a:schemeClr val="lt1"/>
+          </a:fontRef>
+        </p:style>
+        <p:txBody>
+          <a:bodyPr rtlCol="0" anchor="ctr"/>
+          <a:lstStyle/>
+          <a:p>
+            <a:pPr algn="ctr"/>
+            <a:endParaRPr lang="de-DE" dirty="0">
+              <a:solidFill>
+                <a:srgbClr val="A5355C"/>
+              </a:solidFill>
+              <a:latin typeface="Lucida Console" panose="020B0609040504020204" pitchFamily="49" charset="0"/>
+            </a:endParaRPr>
+          </a:p>
+        </p:txBody>
+      </p:sp>
+      <p:sp>
+        <p:nvSpPr>
+          <p:cNvPr id="15" name="Rectangle 14">
+            <a:extLst>
+              <a:ext uri="{FF2B5EF4-FFF2-40B4-BE49-F238E27FC236}">
+                <a16:creationId xmlns:a16="http://schemas.microsoft.com/office/drawing/2014/main" id="{BF46978A-D06B-6ADB-4465-0B8181D6085A}"/>
+              </a:ext>
+            </a:extLst>
+          </p:cNvPr>
+          <p:cNvSpPr/>
+          <p:nvPr/>
+        </p:nvSpPr>
+        <p:spPr>
+          <a:xfrm>
+            <a:off x="5060989" y="1015475"/>
+            <a:ext cx="504884" cy="224294"/>
+          </a:xfrm>
+          <a:prstGeom prst="rect">
+            <a:avLst/>
+          </a:prstGeom>
+          <a:noFill/>
+          <a:ln>
+            <a:solidFill>
+              <a:srgbClr val="A5355C"/>
+            </a:solidFill>
+          </a:ln>
+        </p:spPr>
+        <p:style>
+          <a:lnRef idx="2">
+            <a:schemeClr val="accent1">
+              <a:shade val="15000"/>
+            </a:schemeClr>
+          </a:lnRef>
+          <a:fillRef idx="1">
+            <a:schemeClr val="accent1"/>
+          </a:fillRef>
+          <a:effectRef idx="0">
+            <a:schemeClr val="accent1"/>
+          </a:effectRef>
+          <a:fontRef idx="minor">
+            <a:schemeClr val="lt1"/>
+          </a:fontRef>
+        </p:style>
+        <p:txBody>
+          <a:bodyPr rtlCol="0" anchor="ctr"/>
+          <a:lstStyle/>
+          <a:p>
+            <a:pPr algn="ctr"/>
+            <a:endParaRPr lang="de-DE" dirty="0">
+              <a:solidFill>
+                <a:srgbClr val="A5355C"/>
+              </a:solidFill>
+              <a:latin typeface="Lucida Console" panose="020B0609040504020204" pitchFamily="49" charset="0"/>
+            </a:endParaRPr>
+          </a:p>
+        </p:txBody>
+      </p:sp>
+      <p:sp>
+        <p:nvSpPr>
+          <p:cNvPr id="16" name="Rectangle 15">
+            <a:extLst>
+              <a:ext uri="{FF2B5EF4-FFF2-40B4-BE49-F238E27FC236}">
+                <a16:creationId xmlns:a16="http://schemas.microsoft.com/office/drawing/2014/main" id="{51AD94AE-BFF1-D627-76E4-8CEB27C34E1E}"/>
+              </a:ext>
+            </a:extLst>
+          </p:cNvPr>
+          <p:cNvSpPr/>
+          <p:nvPr/>
+        </p:nvSpPr>
+        <p:spPr>
+          <a:xfrm>
+            <a:off x="579680" y="2337099"/>
+            <a:ext cx="1282777" cy="243416"/>
+          </a:xfrm>
+          <a:prstGeom prst="rect">
+            <a:avLst/>
+          </a:prstGeom>
+          <a:noFill/>
+          <a:ln>
+            <a:solidFill>
+              <a:srgbClr val="A5355C"/>
+            </a:solidFill>
+          </a:ln>
+        </p:spPr>
+        <p:style>
+          <a:lnRef idx="2">
+            <a:schemeClr val="accent1">
+              <a:shade val="15000"/>
+            </a:schemeClr>
+          </a:lnRef>
+          <a:fillRef idx="1">
+            <a:schemeClr val="accent1"/>
+          </a:fillRef>
+          <a:effectRef idx="0">
+            <a:schemeClr val="accent1"/>
+          </a:effectRef>
+          <a:fontRef idx="minor">
+            <a:schemeClr val="lt1"/>
+          </a:fontRef>
+        </p:style>
+        <p:txBody>
+          <a:bodyPr rtlCol="0" anchor="ctr"/>
+          <a:lstStyle/>
+          <a:p>
+            <a:pPr algn="ctr"/>
+            <a:endParaRPr lang="de-DE" dirty="0">
+              <a:solidFill>
+                <a:srgbClr val="A5355C"/>
+              </a:solidFill>
+              <a:latin typeface="Lucida Console" panose="020B0609040504020204" pitchFamily="49" charset="0"/>
+            </a:endParaRPr>
+          </a:p>
+        </p:txBody>
+      </p:sp>
+      <p:sp>
+        <p:nvSpPr>
+          <p:cNvPr id="17" name="Rectangle 16">
+            <a:extLst>
+              <a:ext uri="{FF2B5EF4-FFF2-40B4-BE49-F238E27FC236}">
+                <a16:creationId xmlns:a16="http://schemas.microsoft.com/office/drawing/2014/main" id="{57AA0D11-8369-34FD-73D6-7DC39C402450}"/>
+              </a:ext>
+            </a:extLst>
+          </p:cNvPr>
+          <p:cNvSpPr/>
+          <p:nvPr/>
+        </p:nvSpPr>
+        <p:spPr>
+          <a:xfrm>
+            <a:off x="1862458" y="1286949"/>
+            <a:ext cx="948060" cy="243416"/>
+          </a:xfrm>
+          <a:prstGeom prst="rect">
+            <a:avLst/>
+          </a:prstGeom>
+          <a:noFill/>
+          <a:ln>
+            <a:solidFill>
+              <a:srgbClr val="A5355C"/>
+            </a:solidFill>
+          </a:ln>
+        </p:spPr>
+        <p:style>
+          <a:lnRef idx="2">
+            <a:schemeClr val="accent1">
+              <a:shade val="15000"/>
+            </a:schemeClr>
+          </a:lnRef>
+          <a:fillRef idx="1">
+            <a:schemeClr val="accent1"/>
+          </a:fillRef>
+          <a:effectRef idx="0">
+            <a:schemeClr val="accent1"/>
+          </a:effectRef>
+          <a:fontRef idx="minor">
+            <a:schemeClr val="lt1"/>
+          </a:fontRef>
+        </p:style>
+        <p:txBody>
+          <a:bodyPr rtlCol="0" anchor="ctr"/>
+          <a:lstStyle/>
+          <a:p>
+            <a:pPr algn="ctr"/>
+            <a:endParaRPr lang="de-DE" dirty="0">
+              <a:solidFill>
+                <a:srgbClr val="A5355C"/>
+              </a:solidFill>
+              <a:latin typeface="Lucida Console" panose="020B0609040504020204" pitchFamily="49" charset="0"/>
+            </a:endParaRPr>
+          </a:p>
+        </p:txBody>
+      </p:sp>
+      <p:pic>
+        <p:nvPicPr>
+          <p:cNvPr id="18" name="Picture 4" descr="Stock-Vektorgrafik „Censor blur effect texture. Skin tone colored pixel  mosaic pattern to hide face, body, text or another unwanted content.  Parental control concept“ | Adobe Stock">
+            <a:extLst>
+              <a:ext uri="{FF2B5EF4-FFF2-40B4-BE49-F238E27FC236}">
+                <a16:creationId xmlns:a16="http://schemas.microsoft.com/office/drawing/2014/main" id="{EB3EA98E-1906-5969-9881-95C01800E215}"/>
+              </a:ext>
+            </a:extLst>
+          </p:cNvPr>
+          <p:cNvPicPr>
+            <a:picLocks noChangeAspect="1" noChangeArrowheads="1"/>
+          </p:cNvPicPr>
+          <p:nvPr/>
+        </p:nvPicPr>
+        <p:blipFill rotWithShape="1">
+          <a:blip r:embed="rId5">
+            <a:alphaModFix amt="70000"/>
+            <a:extLst>
+              <a:ext uri="{28A0092B-C50C-407E-A947-70E740481C1C}">
+                <a14:useLocalDpi xmlns:a14="http://schemas.microsoft.com/office/drawing/2010/main" val="0"/>
+              </a:ext>
+            </a:extLst>
+          </a:blip>
+          <a:srcRect l="14069" t="21339" r="14035" b="20226"/>
+          <a:stretch>
+            <a:fillRect/>
+          </a:stretch>
+        </p:blipFill>
+        <p:spPr bwMode="auto">
+          <a:xfrm>
+            <a:off x="6291091" y="4546195"/>
+            <a:ext cx="1512592" cy="345565"/>
+          </a:xfrm>
+          <a:prstGeom prst="rect">
+            <a:avLst/>
+          </a:prstGeom>
+          <a:noFill/>
+          <a:extLst>
+            <a:ext uri="{909E8E84-426E-40DD-AFC4-6F175D3DCCD1}">
+              <a14:hiddenFill xmlns:a14="http://schemas.microsoft.com/office/drawing/2010/main">
+                <a:solidFill>
+                  <a:srgbClr val="FFFFFF"/>
+                </a:solidFill>
+              </a14:hiddenFill>
+            </a:ext>
+          </a:extLst>
+        </p:spPr>
+      </p:pic>
+      <p:pic>
+        <p:nvPicPr>
+          <p:cNvPr id="19" name="Picture 4" descr="Stock-Vektorgrafik „Censor blur effect texture. Skin tone colored pixel  mosaic pattern to hide face, body, text or another unwanted content.  Parental control concept“ | Adobe Stock">
+            <a:extLst>
+              <a:ext uri="{FF2B5EF4-FFF2-40B4-BE49-F238E27FC236}">
+                <a16:creationId xmlns:a16="http://schemas.microsoft.com/office/drawing/2014/main" id="{85C97190-CD54-D6B1-74AB-89BB42D34C73}"/>
+              </a:ext>
+            </a:extLst>
+          </p:cNvPr>
+          <p:cNvPicPr>
+            <a:picLocks noChangeAspect="1" noChangeArrowheads="1"/>
+          </p:cNvPicPr>
+          <p:nvPr/>
+        </p:nvPicPr>
+        <p:blipFill rotWithShape="1">
+          <a:blip r:embed="rId5">
+            <a:alphaModFix amt="70000"/>
+            <a:extLst>
+              <a:ext uri="{28A0092B-C50C-407E-A947-70E740481C1C}">
+                <a14:useLocalDpi xmlns:a14="http://schemas.microsoft.com/office/drawing/2010/main" val="0"/>
+              </a:ext>
+            </a:extLst>
+          </a:blip>
+          <a:srcRect l="14069" t="21339" r="14035" b="20226"/>
+          <a:stretch>
+            <a:fillRect/>
+          </a:stretch>
+        </p:blipFill>
+        <p:spPr bwMode="auto">
+          <a:xfrm>
+            <a:off x="9690177" y="4365934"/>
+            <a:ext cx="458197" cy="104679"/>
+          </a:xfrm>
+          <a:prstGeom prst="rect">
+            <a:avLst/>
+          </a:prstGeom>
+          <a:noFill/>
+          <a:extLst>
+            <a:ext uri="{909E8E84-426E-40DD-AFC4-6F175D3DCCD1}">
+              <a14:hiddenFill xmlns:a14="http://schemas.microsoft.com/office/drawing/2010/main">
+                <a:solidFill>
+                  <a:srgbClr val="FFFFFF"/>
+                </a:solidFill>
+              </a14:hiddenFill>
+            </a:ext>
+          </a:extLst>
+        </p:spPr>
+      </p:pic>
+      <p:pic>
+        <p:nvPicPr>
+          <p:cNvPr id="20" name="Picture 4" descr="Stock-Vektorgrafik „Censor blur effect texture. Skin tone colored pixel  mosaic pattern to hide face, body, text or another unwanted content.  Parental control concept“ | Adobe Stock">
+            <a:extLst>
+              <a:ext uri="{FF2B5EF4-FFF2-40B4-BE49-F238E27FC236}">
+                <a16:creationId xmlns:a16="http://schemas.microsoft.com/office/drawing/2014/main" id="{2FDA3367-3E85-4BFA-6EB3-B4D9EF7045FE}"/>
+              </a:ext>
+            </a:extLst>
+          </p:cNvPr>
+          <p:cNvPicPr>
+            <a:picLocks noChangeAspect="1" noChangeArrowheads="1"/>
+          </p:cNvPicPr>
+          <p:nvPr/>
+        </p:nvPicPr>
+        <p:blipFill rotWithShape="1">
+          <a:blip r:embed="rId5">
+            <a:alphaModFix amt="70000"/>
+            <a:extLst>
+              <a:ext uri="{28A0092B-C50C-407E-A947-70E740481C1C}">
+                <a14:useLocalDpi xmlns:a14="http://schemas.microsoft.com/office/drawing/2010/main" val="0"/>
+              </a:ext>
+            </a:extLst>
+          </a:blip>
+          <a:srcRect l="14069" t="21339" r="14035" b="20226"/>
+          <a:stretch>
+            <a:fillRect/>
+          </a:stretch>
+        </p:blipFill>
+        <p:spPr bwMode="auto">
+          <a:xfrm>
+            <a:off x="9716321" y="3345683"/>
+            <a:ext cx="521593" cy="104679"/>
+          </a:xfrm>
+          <a:prstGeom prst="rect">
+            <a:avLst/>
+          </a:prstGeom>
+          <a:noFill/>
+          <a:extLst>
+            <a:ext uri="{909E8E84-426E-40DD-AFC4-6F175D3DCCD1}">
+              <a14:hiddenFill xmlns:a14="http://schemas.microsoft.com/office/drawing/2010/main">
+                <a:solidFill>
+                  <a:srgbClr val="FFFFFF"/>
+                </a:solidFill>
+              </a14:hiddenFill>
+            </a:ext>
+          </a:extLst>
+        </p:spPr>
+      </p:pic>
+    </p:spTree>
+    <p:extLst>
+      <p:ext uri="{BB962C8B-B14F-4D97-AF65-F5344CB8AC3E}">
+        <p14:creationId xmlns:p14="http://schemas.microsoft.com/office/powerpoint/2010/main" val="3120794841"/>
+      </p:ext>
+    </p:extLst>
+  </p:cSld>
+  <p:clrMapOvr>
+    <a:masterClrMapping/>
+  </p:clrMapOvr>
+</p:sld>
+</file>
+
+<file path=ppt/slides/slide9.xml><?xml version="1.0" encoding="utf-8"?>
+<p:sld xmlns:a="http://schemas.openxmlformats.org/drawingml/2006/main" xmlns:r="http://schemas.openxmlformats.org/officeDocument/2006/relationships" xmlns:p="http://schemas.openxmlformats.org/presentationml/2006/main">
+  <p:cSld>
+    <p:spTree>
+      <p:nvGrpSpPr>
+        <p:cNvPr id="1" name=""/>
+        <p:cNvGrpSpPr/>
+        <p:nvPr/>
+      </p:nvGrpSpPr>
+      <p:grpSpPr>
+        <a:xfrm>
+          <a:off x="0" y="0"/>
+          <a:ext cx="0" cy="0"/>
+          <a:chOff x="0" y="0"/>
+          <a:chExt cx="0" cy="0"/>
+        </a:xfrm>
+      </p:grpSpPr>
+      <p:pic>
+        <p:nvPicPr>
+          <p:cNvPr id="7" name="Picture 6">
+            <a:extLst>
+              <a:ext uri="{FF2B5EF4-FFF2-40B4-BE49-F238E27FC236}">
+                <a16:creationId xmlns:a16="http://schemas.microsoft.com/office/drawing/2014/main" id="{6922C84B-CEC9-6D0A-FCDE-99F2497D95C5}"/>
+              </a:ext>
+            </a:extLst>
+          </p:cNvPr>
+          <p:cNvPicPr>
+            <a:picLocks noChangeAspect="1"/>
+          </p:cNvPicPr>
+          <p:nvPr/>
+        </p:nvPicPr>
+        <p:blipFill>
+          <a:blip r:embed="rId2"/>
+          <a:stretch>
+            <a:fillRect/>
+          </a:stretch>
+        </p:blipFill>
+        <p:spPr>
+          <a:xfrm>
+            <a:off x="740203" y="764445"/>
+            <a:ext cx="5553116" cy="5076862"/>
+          </a:xfrm>
+          <a:prstGeom prst="rect">
+            <a:avLst/>
+          </a:prstGeom>
+        </p:spPr>
+      </p:pic>
+      <p:sp>
+        <p:nvSpPr>
+          <p:cNvPr id="15" name="Rectangle 14">
+            <a:extLst>
+              <a:ext uri="{FF2B5EF4-FFF2-40B4-BE49-F238E27FC236}">
+                <a16:creationId xmlns:a16="http://schemas.microsoft.com/office/drawing/2014/main" id="{9062EB4E-33E9-B2B4-BA52-C54D56557FCC}"/>
+              </a:ext>
+            </a:extLst>
+          </p:cNvPr>
+          <p:cNvSpPr/>
+          <p:nvPr/>
+        </p:nvSpPr>
+        <p:spPr>
+          <a:xfrm>
+            <a:off x="1004428" y="4425155"/>
+            <a:ext cx="1051396" cy="487154"/>
+          </a:xfrm>
+          <a:prstGeom prst="rect">
+            <a:avLst/>
+          </a:prstGeom>
+          <a:noFill/>
+          <a:ln>
+            <a:solidFill>
+              <a:srgbClr val="A5355C"/>
+            </a:solidFill>
+          </a:ln>
+        </p:spPr>
+        <p:style>
+          <a:lnRef idx="2">
+            <a:schemeClr val="accent1">
+              <a:shade val="15000"/>
+            </a:schemeClr>
+          </a:lnRef>
+          <a:fillRef idx="1">
+            <a:schemeClr val="accent1"/>
+          </a:fillRef>
+          <a:effectRef idx="0">
+            <a:schemeClr val="accent1"/>
+          </a:effectRef>
+          <a:fontRef idx="minor">
+            <a:schemeClr val="lt1"/>
+          </a:fontRef>
+        </p:style>
+        <p:txBody>
+          <a:bodyPr rtlCol="0" anchor="ctr"/>
+          <a:lstStyle/>
+          <a:p>
+            <a:pPr algn="ctr"/>
+            <a:endParaRPr lang="de-DE" dirty="0">
+              <a:solidFill>
+                <a:srgbClr val="A5355C"/>
+              </a:solidFill>
+              <a:latin typeface="Lucida Console" panose="020B0609040504020204" pitchFamily="49" charset="0"/>
+            </a:endParaRPr>
+          </a:p>
+        </p:txBody>
+      </p:sp>
+      <p:sp>
+        <p:nvSpPr>
+          <p:cNvPr id="16" name="Rectangle 15">
+            <a:extLst>
+              <a:ext uri="{FF2B5EF4-FFF2-40B4-BE49-F238E27FC236}">
+                <a16:creationId xmlns:a16="http://schemas.microsoft.com/office/drawing/2014/main" id="{4F44DFCB-B62B-A3A4-9A79-27CEFA979D0D}"/>
+              </a:ext>
+            </a:extLst>
+          </p:cNvPr>
+          <p:cNvSpPr/>
+          <p:nvPr/>
+        </p:nvSpPr>
+        <p:spPr>
+          <a:xfrm>
+            <a:off x="1004428" y="3429000"/>
+            <a:ext cx="1051396" cy="487154"/>
+          </a:xfrm>
+          <a:prstGeom prst="rect">
+            <a:avLst/>
+          </a:prstGeom>
+          <a:noFill/>
+          <a:ln>
+            <a:solidFill>
+              <a:srgbClr val="A5355C"/>
+            </a:solidFill>
+          </a:ln>
+        </p:spPr>
+        <p:style>
+          <a:lnRef idx="2">
+            <a:schemeClr val="accent1">
+              <a:shade val="15000"/>
+            </a:schemeClr>
+          </a:lnRef>
+          <a:fillRef idx="1">
+            <a:schemeClr val="accent1"/>
+          </a:fillRef>
+          <a:effectRef idx="0">
+            <a:schemeClr val="accent1"/>
+          </a:effectRef>
+          <a:fontRef idx="minor">
+            <a:schemeClr val="lt1"/>
+          </a:fontRef>
+        </p:style>
+        <p:txBody>
+          <a:bodyPr rtlCol="0" anchor="ctr"/>
+          <a:lstStyle/>
+          <a:p>
+            <a:pPr algn="ctr"/>
+            <a:endParaRPr lang="de-DE" dirty="0">
+              <a:solidFill>
+                <a:srgbClr val="A5355C"/>
+              </a:solidFill>
+              <a:latin typeface="Lucida Console" panose="020B0609040504020204" pitchFamily="49" charset="0"/>
+            </a:endParaRPr>
+          </a:p>
+        </p:txBody>
+      </p:sp>
+    </p:spTree>
+    <p:extLst>
+      <p:ext uri="{BB962C8B-B14F-4D97-AF65-F5344CB8AC3E}">
+        <p14:creationId xmlns:p14="http://schemas.microsoft.com/office/powerpoint/2010/main" val="2774789794"/>
       </p:ext>
     </p:extLst>
   </p:cSld>

</xml_diff>

<commit_message>
Document POST & PATCH requests
</commit_message>
<xml_diff>
--- a/vignettes/images/images.pptx
+++ b/vignettes/images/images.pptx
@@ -5,7 +5,7 @@
     <p:sldMasterId id="2147483648" r:id="rId1"/>
   </p:sldMasterIdLst>
   <p:notesMasterIdLst>
-    <p:notesMasterId r:id="rId16"/>
+    <p:notesMasterId r:id="rId17"/>
   </p:notesMasterIdLst>
   <p:sldIdLst>
     <p:sldId id="257" r:id="rId2"/>
@@ -21,7 +21,8 @@
     <p:sldId id="267" r:id="rId12"/>
     <p:sldId id="268" r:id="rId13"/>
     <p:sldId id="269" r:id="rId14"/>
-    <p:sldId id="270" r:id="rId15"/>
+    <p:sldId id="273" r:id="rId15"/>
+    <p:sldId id="274" r:id="rId16"/>
   </p:sldIdLst>
   <p:sldSz cx="12192000" cy="6858000"/>
   <p:notesSz cx="6858000" cy="9144000"/>
@@ -5442,13 +5443,7 @@
   <p:cSld>
     <p:spTree>
       <p:nvGrpSpPr>
-        <p:cNvPr id="1" name="">
-          <a:extLst>
-            <a:ext uri="{FF2B5EF4-FFF2-40B4-BE49-F238E27FC236}">
-              <a16:creationId xmlns:a16="http://schemas.microsoft.com/office/drawing/2014/main" id="{AA9CB644-A465-F547-78AC-B6408F81960B}"/>
-            </a:ext>
-          </a:extLst>
-        </p:cNvPr>
+        <p:cNvPr id="1" name=""/>
         <p:cNvGrpSpPr/>
         <p:nvPr/>
       </p:nvGrpSpPr>
@@ -5462,10 +5457,10 @@
       </p:grpSpPr>
       <p:pic>
         <p:nvPicPr>
-          <p:cNvPr id="3" name="Picture 2">
-            <a:extLst>
-              <a:ext uri="{FF2B5EF4-FFF2-40B4-BE49-F238E27FC236}">
-                <a16:creationId xmlns:a16="http://schemas.microsoft.com/office/drawing/2014/main" id="{5DE84168-FDF6-258A-54BC-5EE28899DE19}"/>
+          <p:cNvPr id="6" name="Picture 5">
+            <a:extLst>
+              <a:ext uri="{FF2B5EF4-FFF2-40B4-BE49-F238E27FC236}">
+                <a16:creationId xmlns:a16="http://schemas.microsoft.com/office/drawing/2014/main" id="{C84E9670-4EB3-F5E4-C9C8-E26E62F14E28}"/>
               </a:ext>
             </a:extLst>
           </p:cNvPr>
@@ -5482,18 +5477,688 @@
         </p:blipFill>
         <p:spPr>
           <a:xfrm>
-            <a:off x="532171" y="640247"/>
-            <a:ext cx="11127658" cy="4888686"/>
+            <a:off x="526764" y="209526"/>
+            <a:ext cx="8277286" cy="6438947"/>
           </a:xfrm>
           <a:prstGeom prst="rect">
             <a:avLst/>
           </a:prstGeom>
+        </p:spPr>
+      </p:pic>
+      <p:pic>
+        <p:nvPicPr>
+          <p:cNvPr id="12" name="Picture 11">
+            <a:extLst>
+              <a:ext uri="{FF2B5EF4-FFF2-40B4-BE49-F238E27FC236}">
+                <a16:creationId xmlns:a16="http://schemas.microsoft.com/office/drawing/2014/main" id="{72008AAB-67AD-3B34-3912-2981FC9F178F}"/>
+              </a:ext>
+            </a:extLst>
+          </p:cNvPr>
+          <p:cNvPicPr>
+            <a:picLocks noChangeAspect="1"/>
+          </p:cNvPicPr>
+          <p:nvPr/>
+        </p:nvPicPr>
+        <p:blipFill>
+          <a:blip r:embed="rId3"/>
+          <a:stretch>
+            <a:fillRect/>
+          </a:stretch>
+        </p:blipFill>
+        <p:spPr>
+          <a:xfrm>
+            <a:off x="2649981" y="1817912"/>
+            <a:ext cx="2886096" cy="609604"/>
+          </a:xfrm>
+          <a:prstGeom prst="rect">
+            <a:avLst/>
+          </a:prstGeom>
+        </p:spPr>
+      </p:pic>
+      <p:pic>
+        <p:nvPicPr>
+          <p:cNvPr id="14" name="Picture 13">
+            <a:extLst>
+              <a:ext uri="{FF2B5EF4-FFF2-40B4-BE49-F238E27FC236}">
+                <a16:creationId xmlns:a16="http://schemas.microsoft.com/office/drawing/2014/main" id="{9F9698AC-C17F-5F3B-7B05-4131A36B8CF6}"/>
+              </a:ext>
+            </a:extLst>
+          </p:cNvPr>
+          <p:cNvPicPr>
+            <a:picLocks noChangeAspect="1"/>
+          </p:cNvPicPr>
+          <p:nvPr/>
+        </p:nvPicPr>
+        <p:blipFill>
+          <a:blip r:embed="rId4"/>
+          <a:stretch>
+            <a:fillRect/>
+          </a:stretch>
+        </p:blipFill>
+        <p:spPr>
+          <a:xfrm>
+            <a:off x="6741872" y="4927602"/>
+            <a:ext cx="5053774" cy="1493160"/>
+          </a:xfrm>
+          <a:prstGeom prst="rect">
+            <a:avLst/>
+          </a:prstGeom>
+          <a:ln w="38100">
+            <a:solidFill>
+              <a:srgbClr val="A5355C"/>
+            </a:solidFill>
+          </a:ln>
+        </p:spPr>
+      </p:pic>
+      <p:sp>
+        <p:nvSpPr>
+          <p:cNvPr id="15" name="Rectangle 14">
+            <a:extLst>
+              <a:ext uri="{FF2B5EF4-FFF2-40B4-BE49-F238E27FC236}">
+                <a16:creationId xmlns:a16="http://schemas.microsoft.com/office/drawing/2014/main" id="{4BB9F58C-E9CC-BDBB-15A9-4E71FE4BEA4E}"/>
+              </a:ext>
+            </a:extLst>
+          </p:cNvPr>
+          <p:cNvSpPr/>
+          <p:nvPr/>
+        </p:nvSpPr>
+        <p:spPr>
+          <a:xfrm>
+            <a:off x="5147940" y="4748205"/>
+            <a:ext cx="770416" cy="334287"/>
+          </a:xfrm>
+          <a:prstGeom prst="rect">
+            <a:avLst/>
+          </a:prstGeom>
+          <a:noFill/>
+          <a:ln>
+            <a:solidFill>
+              <a:srgbClr val="A5355C"/>
+            </a:solidFill>
+          </a:ln>
+        </p:spPr>
+        <p:style>
+          <a:lnRef idx="2">
+            <a:schemeClr val="accent1">
+              <a:shade val="15000"/>
+            </a:schemeClr>
+          </a:lnRef>
+          <a:fillRef idx="1">
+            <a:schemeClr val="accent1"/>
+          </a:fillRef>
+          <a:effectRef idx="0">
+            <a:schemeClr val="accent1"/>
+          </a:effectRef>
+          <a:fontRef idx="minor">
+            <a:schemeClr val="lt1"/>
+          </a:fontRef>
+        </p:style>
+        <p:txBody>
+          <a:bodyPr rtlCol="0" anchor="ctr"/>
+          <a:lstStyle/>
+          <a:p>
+            <a:pPr algn="ctr"/>
+            <a:endParaRPr lang="de-DE" dirty="0">
+              <a:solidFill>
+                <a:srgbClr val="A5355C"/>
+              </a:solidFill>
+              <a:latin typeface="Lucida Console" panose="020B0609040504020204" pitchFamily="49" charset="0"/>
+            </a:endParaRPr>
+          </a:p>
+        </p:txBody>
+      </p:sp>
+      <p:cxnSp>
+        <p:nvCxnSpPr>
+          <p:cNvPr id="16" name="Straight Arrow Connector 15">
+            <a:extLst>
+              <a:ext uri="{FF2B5EF4-FFF2-40B4-BE49-F238E27FC236}">
+                <a16:creationId xmlns:a16="http://schemas.microsoft.com/office/drawing/2014/main" id="{F971C558-50C1-0F06-CA2D-42FB73373944}"/>
+              </a:ext>
+            </a:extLst>
+          </p:cNvPr>
+          <p:cNvCxnSpPr>
+            <a:cxnSpLocks/>
+            <a:stCxn id="23" idx="3"/>
+          </p:cNvCxnSpPr>
+          <p:nvPr/>
+        </p:nvCxnSpPr>
+        <p:spPr>
+          <a:xfrm flipV="1">
+            <a:off x="6095999" y="4927602"/>
+            <a:ext cx="645873" cy="1079611"/>
+          </a:xfrm>
+          <a:prstGeom prst="straightConnector1">
+            <a:avLst/>
+          </a:prstGeom>
+          <a:ln w="38100" cap="flat" cmpd="sng" algn="ctr">
+            <a:solidFill>
+              <a:srgbClr val="A5355C"/>
+            </a:solidFill>
+            <a:prstDash val="solid"/>
+            <a:round/>
+            <a:headEnd type="none" w="med" len="med"/>
+            <a:tailEnd type="arrow" w="med" len="med"/>
+          </a:ln>
+        </p:spPr>
+        <p:style>
+          <a:lnRef idx="0">
+            <a:scrgbClr r="0" g="0" b="0"/>
+          </a:lnRef>
+          <a:fillRef idx="0">
+            <a:scrgbClr r="0" g="0" b="0"/>
+          </a:fillRef>
+          <a:effectRef idx="0">
+            <a:scrgbClr r="0" g="0" b="0"/>
+          </a:effectRef>
+          <a:fontRef idx="minor">
+            <a:schemeClr val="tx1"/>
+          </a:fontRef>
+        </p:style>
+      </p:cxnSp>
+      <p:cxnSp>
+        <p:nvCxnSpPr>
+          <p:cNvPr id="19" name="Straight Arrow Connector 18">
+            <a:extLst>
+              <a:ext uri="{FF2B5EF4-FFF2-40B4-BE49-F238E27FC236}">
+                <a16:creationId xmlns:a16="http://schemas.microsoft.com/office/drawing/2014/main" id="{43DB7394-7D13-DCF9-0F5D-85A21ACC286F}"/>
+              </a:ext>
+            </a:extLst>
+          </p:cNvPr>
+          <p:cNvCxnSpPr>
+            <a:cxnSpLocks/>
+            <a:stCxn id="23" idx="3"/>
+          </p:cNvCxnSpPr>
+          <p:nvPr/>
+        </p:nvCxnSpPr>
+        <p:spPr>
+          <a:xfrm>
+            <a:off x="6095999" y="6007213"/>
+            <a:ext cx="645873" cy="413549"/>
+          </a:xfrm>
+          <a:prstGeom prst="straightConnector1">
+            <a:avLst/>
+          </a:prstGeom>
+          <a:ln w="38100" cap="flat" cmpd="sng" algn="ctr">
+            <a:solidFill>
+              <a:srgbClr val="A5355C"/>
+            </a:solidFill>
+            <a:prstDash val="solid"/>
+            <a:round/>
+            <a:headEnd type="none" w="med" len="med"/>
+            <a:tailEnd type="arrow" w="med" len="med"/>
+          </a:ln>
+        </p:spPr>
+        <p:style>
+          <a:lnRef idx="0">
+            <a:scrgbClr r="0" g="0" b="0"/>
+          </a:lnRef>
+          <a:fillRef idx="0">
+            <a:scrgbClr r="0" g="0" b="0"/>
+          </a:fillRef>
+          <a:effectRef idx="0">
+            <a:scrgbClr r="0" g="0" b="0"/>
+          </a:effectRef>
+          <a:fontRef idx="minor">
+            <a:schemeClr val="tx1"/>
+          </a:fontRef>
+        </p:style>
+      </p:cxnSp>
+      <p:sp>
+        <p:nvSpPr>
+          <p:cNvPr id="23" name="Rectangle 22">
+            <a:extLst>
+              <a:ext uri="{FF2B5EF4-FFF2-40B4-BE49-F238E27FC236}">
+                <a16:creationId xmlns:a16="http://schemas.microsoft.com/office/drawing/2014/main" id="{B34C1D66-C95E-1ACF-C755-EFB9295D269F}"/>
+              </a:ext>
+            </a:extLst>
+          </p:cNvPr>
+          <p:cNvSpPr/>
+          <p:nvPr/>
+        </p:nvSpPr>
+        <p:spPr>
+          <a:xfrm>
+            <a:off x="3707820" y="5507038"/>
+            <a:ext cx="2388179" cy="1000349"/>
+          </a:xfrm>
+          <a:prstGeom prst="rect">
+            <a:avLst/>
+          </a:prstGeom>
+          <a:noFill/>
+          <a:ln>
+            <a:solidFill>
+              <a:srgbClr val="A5355C"/>
+            </a:solidFill>
+          </a:ln>
+        </p:spPr>
+        <p:style>
+          <a:lnRef idx="2">
+            <a:schemeClr val="accent1">
+              <a:shade val="15000"/>
+            </a:schemeClr>
+          </a:lnRef>
+          <a:fillRef idx="1">
+            <a:schemeClr val="accent1"/>
+          </a:fillRef>
+          <a:effectRef idx="0">
+            <a:schemeClr val="accent1"/>
+          </a:effectRef>
+          <a:fontRef idx="minor">
+            <a:schemeClr val="lt1"/>
+          </a:fontRef>
+        </p:style>
+        <p:txBody>
+          <a:bodyPr rtlCol="0" anchor="ctr"/>
+          <a:lstStyle/>
+          <a:p>
+            <a:pPr algn="ctr"/>
+            <a:endParaRPr lang="de-DE" dirty="0">
+              <a:solidFill>
+                <a:srgbClr val="A5355C"/>
+              </a:solidFill>
+              <a:latin typeface="Lucida Console" panose="020B0609040504020204" pitchFamily="49" charset="0"/>
+            </a:endParaRPr>
+          </a:p>
+        </p:txBody>
+      </p:sp>
+      <p:pic>
+        <p:nvPicPr>
+          <p:cNvPr id="27" name="Picture 4" descr="Stock-Vektorgrafik „Censor blur effect texture. Skin tone colored pixel  mosaic pattern to hide face, body, text or another unwanted content.  Parental control concept“ | Adobe Stock">
+            <a:extLst>
+              <a:ext uri="{FF2B5EF4-FFF2-40B4-BE49-F238E27FC236}">
+                <a16:creationId xmlns:a16="http://schemas.microsoft.com/office/drawing/2014/main" id="{6C5D8657-C78A-3580-CA03-573DD042D83F}"/>
+              </a:ext>
+            </a:extLst>
+          </p:cNvPr>
+          <p:cNvPicPr>
+            <a:picLocks noChangeAspect="1" noChangeArrowheads="1"/>
+          </p:cNvPicPr>
+          <p:nvPr/>
+        </p:nvPicPr>
+        <p:blipFill rotWithShape="1">
+          <a:blip r:embed="rId5">
+            <a:alphaModFix amt="70000"/>
+            <a:extLst>
+              <a:ext uri="{28A0092B-C50C-407E-A947-70E740481C1C}">
+                <a14:useLocalDpi xmlns:a14="http://schemas.microsoft.com/office/drawing/2010/main" val="0"/>
+              </a:ext>
+            </a:extLst>
+          </a:blip>
+          <a:srcRect l="14069" t="21339" r="14035" b="20226"/>
+          <a:stretch>
+            <a:fillRect/>
+          </a:stretch>
+        </p:blipFill>
+        <p:spPr bwMode="auto">
+          <a:xfrm>
+            <a:off x="4348382" y="6322979"/>
+            <a:ext cx="724378" cy="97783"/>
+          </a:xfrm>
+          <a:prstGeom prst="rect">
+            <a:avLst/>
+          </a:prstGeom>
+          <a:noFill/>
+          <a:extLst>
+            <a:ext uri="{909E8E84-426E-40DD-AFC4-6F175D3DCCD1}">
+              <a14:hiddenFill xmlns:a14="http://schemas.microsoft.com/office/drawing/2010/main">
+                <a:solidFill>
+                  <a:srgbClr val="FFFFFF"/>
+                </a:solidFill>
+              </a14:hiddenFill>
+            </a:ext>
+          </a:extLst>
+        </p:spPr>
+      </p:pic>
+      <p:pic>
+        <p:nvPicPr>
+          <p:cNvPr id="28" name="Picture 4" descr="Stock-Vektorgrafik „Censor blur effect texture. Skin tone colored pixel  mosaic pattern to hide face, body, text or another unwanted content.  Parental control concept“ | Adobe Stock">
+            <a:extLst>
+              <a:ext uri="{FF2B5EF4-FFF2-40B4-BE49-F238E27FC236}">
+                <a16:creationId xmlns:a16="http://schemas.microsoft.com/office/drawing/2014/main" id="{63C02A0C-4DE5-7E3C-214A-AC6A942479FB}"/>
+              </a:ext>
+            </a:extLst>
+          </p:cNvPr>
+          <p:cNvPicPr>
+            <a:picLocks noChangeAspect="1" noChangeArrowheads="1"/>
+          </p:cNvPicPr>
+          <p:nvPr/>
+        </p:nvPicPr>
+        <p:blipFill rotWithShape="1">
+          <a:blip r:embed="rId5">
+            <a:alphaModFix amt="70000"/>
+            <a:extLst>
+              <a:ext uri="{28A0092B-C50C-407E-A947-70E740481C1C}">
+                <a14:useLocalDpi xmlns:a14="http://schemas.microsoft.com/office/drawing/2010/main" val="0"/>
+              </a:ext>
+            </a:extLst>
+          </a:blip>
+          <a:srcRect l="14069" t="21339" r="14035" b="20226"/>
+          <a:stretch>
+            <a:fillRect/>
+          </a:stretch>
+        </p:blipFill>
+        <p:spPr bwMode="auto">
+          <a:xfrm>
+            <a:off x="4348382" y="6344630"/>
+            <a:ext cx="724378" cy="97783"/>
+          </a:xfrm>
+          <a:prstGeom prst="rect">
+            <a:avLst/>
+          </a:prstGeom>
+          <a:noFill/>
+          <a:extLst>
+            <a:ext uri="{909E8E84-426E-40DD-AFC4-6F175D3DCCD1}">
+              <a14:hiddenFill xmlns:a14="http://schemas.microsoft.com/office/drawing/2010/main">
+                <a:solidFill>
+                  <a:srgbClr val="FFFFFF"/>
+                </a:solidFill>
+              </a14:hiddenFill>
+            </a:ext>
+          </a:extLst>
+        </p:spPr>
+      </p:pic>
+      <p:pic>
+        <p:nvPicPr>
+          <p:cNvPr id="29" name="Picture 4" descr="Stock-Vektorgrafik „Censor blur effect texture. Skin tone colored pixel  mosaic pattern to hide face, body, text or another unwanted content.  Parental control concept“ | Adobe Stock">
+            <a:extLst>
+              <a:ext uri="{FF2B5EF4-FFF2-40B4-BE49-F238E27FC236}">
+                <a16:creationId xmlns:a16="http://schemas.microsoft.com/office/drawing/2014/main" id="{AC7A8D69-F975-A6C3-3DA4-F82C94E5BEEA}"/>
+              </a:ext>
+            </a:extLst>
+          </p:cNvPr>
+          <p:cNvPicPr>
+            <a:picLocks noChangeAspect="1" noChangeArrowheads="1"/>
+          </p:cNvPicPr>
+          <p:nvPr/>
+        </p:nvPicPr>
+        <p:blipFill rotWithShape="1">
+          <a:blip r:embed="rId5">
+            <a:alphaModFix amt="70000"/>
+            <a:extLst>
+              <a:ext uri="{28A0092B-C50C-407E-A947-70E740481C1C}">
+                <a14:useLocalDpi xmlns:a14="http://schemas.microsoft.com/office/drawing/2010/main" val="0"/>
+              </a:ext>
+            </a:extLst>
+          </a:blip>
+          <a:srcRect l="14069" t="21339" r="14035" b="20226"/>
+          <a:stretch>
+            <a:fillRect/>
+          </a:stretch>
+        </p:blipFill>
+        <p:spPr bwMode="auto">
+          <a:xfrm>
+            <a:off x="4124265" y="6115945"/>
+            <a:ext cx="281000" cy="163711"/>
+          </a:xfrm>
+          <a:prstGeom prst="rect">
+            <a:avLst/>
+          </a:prstGeom>
+          <a:noFill/>
+          <a:extLst>
+            <a:ext uri="{909E8E84-426E-40DD-AFC4-6F175D3DCCD1}">
+              <a14:hiddenFill xmlns:a14="http://schemas.microsoft.com/office/drawing/2010/main">
+                <a:solidFill>
+                  <a:srgbClr val="FFFFFF"/>
+                </a:solidFill>
+              </a14:hiddenFill>
+            </a:ext>
+          </a:extLst>
         </p:spPr>
       </p:pic>
     </p:spTree>
     <p:extLst>
       <p:ext uri="{BB962C8B-B14F-4D97-AF65-F5344CB8AC3E}">
-        <p14:creationId xmlns:p14="http://schemas.microsoft.com/office/powerpoint/2010/main" val="3526686268"/>
+        <p14:creationId xmlns:p14="http://schemas.microsoft.com/office/powerpoint/2010/main" val="2898296918"/>
+      </p:ext>
+    </p:extLst>
+  </p:cSld>
+  <p:clrMapOvr>
+    <a:masterClrMapping/>
+  </p:clrMapOvr>
+</p:sld>
+</file>
+
+<file path=ppt/slides/slide15.xml><?xml version="1.0" encoding="utf-8"?>
+<p:sld xmlns:a="http://schemas.openxmlformats.org/drawingml/2006/main" xmlns:r="http://schemas.openxmlformats.org/officeDocument/2006/relationships" xmlns:p="http://schemas.openxmlformats.org/presentationml/2006/main">
+  <p:cSld>
+    <p:spTree>
+      <p:nvGrpSpPr>
+        <p:cNvPr id="1" name=""/>
+        <p:cNvGrpSpPr/>
+        <p:nvPr/>
+      </p:nvGrpSpPr>
+      <p:grpSpPr>
+        <a:xfrm>
+          <a:off x="0" y="0"/>
+          <a:ext cx="0" cy="0"/>
+          <a:chOff x="0" y="0"/>
+          <a:chExt cx="0" cy="0"/>
+        </a:xfrm>
+      </p:grpSpPr>
+      <p:pic>
+        <p:nvPicPr>
+          <p:cNvPr id="5" name="Picture 4">
+            <a:extLst>
+              <a:ext uri="{FF2B5EF4-FFF2-40B4-BE49-F238E27FC236}">
+                <a16:creationId xmlns:a16="http://schemas.microsoft.com/office/drawing/2014/main" id="{C84DC953-79DA-A1C3-4EA6-10BA35280424}"/>
+              </a:ext>
+            </a:extLst>
+          </p:cNvPr>
+          <p:cNvPicPr>
+            <a:picLocks noChangeAspect="1"/>
+          </p:cNvPicPr>
+          <p:nvPr/>
+        </p:nvPicPr>
+        <p:blipFill>
+          <a:blip r:embed="rId2"/>
+          <a:stretch>
+            <a:fillRect/>
+          </a:stretch>
+        </p:blipFill>
+        <p:spPr>
+          <a:xfrm>
+            <a:off x="439978" y="2029310"/>
+            <a:ext cx="5372139" cy="2533669"/>
+          </a:xfrm>
+          <a:prstGeom prst="rect">
+            <a:avLst/>
+          </a:prstGeom>
+        </p:spPr>
+      </p:pic>
+      <p:pic>
+        <p:nvPicPr>
+          <p:cNvPr id="7" name="Picture 6">
+            <a:extLst>
+              <a:ext uri="{FF2B5EF4-FFF2-40B4-BE49-F238E27FC236}">
+                <a16:creationId xmlns:a16="http://schemas.microsoft.com/office/drawing/2014/main" id="{EEB7A002-7EB6-6A72-13A4-4A36F61B0D42}"/>
+              </a:ext>
+            </a:extLst>
+          </p:cNvPr>
+          <p:cNvPicPr>
+            <a:picLocks noChangeAspect="1"/>
+          </p:cNvPicPr>
+          <p:nvPr/>
+        </p:nvPicPr>
+        <p:blipFill>
+          <a:blip r:embed="rId3"/>
+          <a:stretch>
+            <a:fillRect/>
+          </a:stretch>
+        </p:blipFill>
+        <p:spPr>
+          <a:xfrm>
+            <a:off x="6379885" y="2029310"/>
+            <a:ext cx="5467390" cy="2505093"/>
+          </a:xfrm>
+          <a:prstGeom prst="rect">
+            <a:avLst/>
+          </a:prstGeom>
+        </p:spPr>
+      </p:pic>
+      <p:cxnSp>
+        <p:nvCxnSpPr>
+          <p:cNvPr id="8" name="Straight Arrow Connector 7">
+            <a:extLst>
+              <a:ext uri="{FF2B5EF4-FFF2-40B4-BE49-F238E27FC236}">
+                <a16:creationId xmlns:a16="http://schemas.microsoft.com/office/drawing/2014/main" id="{723259AF-4EEF-B8C1-9DA4-A8CCB5DFCCC5}"/>
+              </a:ext>
+            </a:extLst>
+          </p:cNvPr>
+          <p:cNvCxnSpPr>
+            <a:cxnSpLocks/>
+          </p:cNvCxnSpPr>
+          <p:nvPr/>
+        </p:nvCxnSpPr>
+        <p:spPr>
+          <a:xfrm>
+            <a:off x="2002971" y="3684927"/>
+            <a:ext cx="4717143" cy="0"/>
+          </a:xfrm>
+          <a:prstGeom prst="straightConnector1">
+            <a:avLst/>
+          </a:prstGeom>
+          <a:ln w="38100" cap="flat" cmpd="sng" algn="ctr">
+            <a:solidFill>
+              <a:srgbClr val="A5355C"/>
+            </a:solidFill>
+            <a:prstDash val="solid"/>
+            <a:round/>
+            <a:headEnd type="none" w="med" len="med"/>
+            <a:tailEnd type="arrow" w="med" len="med"/>
+          </a:ln>
+        </p:spPr>
+        <p:style>
+          <a:lnRef idx="0">
+            <a:scrgbClr r="0" g="0" b="0"/>
+          </a:lnRef>
+          <a:fillRef idx="0">
+            <a:scrgbClr r="0" g="0" b="0"/>
+          </a:fillRef>
+          <a:effectRef idx="0">
+            <a:scrgbClr r="0" g="0" b="0"/>
+          </a:effectRef>
+          <a:fontRef idx="minor">
+            <a:schemeClr val="tx1"/>
+          </a:fontRef>
+        </p:style>
+      </p:cxnSp>
+      <p:sp>
+        <p:nvSpPr>
+          <p:cNvPr id="10" name="Rectangle 9">
+            <a:extLst>
+              <a:ext uri="{FF2B5EF4-FFF2-40B4-BE49-F238E27FC236}">
+                <a16:creationId xmlns:a16="http://schemas.microsoft.com/office/drawing/2014/main" id="{AD45C550-0468-64A1-36D8-279AB26C499E}"/>
+              </a:ext>
+            </a:extLst>
+          </p:cNvPr>
+          <p:cNvSpPr/>
+          <p:nvPr/>
+        </p:nvSpPr>
+        <p:spPr>
+          <a:xfrm>
+            <a:off x="856023" y="3429000"/>
+            <a:ext cx="943747" cy="439056"/>
+          </a:xfrm>
+          <a:prstGeom prst="rect">
+            <a:avLst/>
+          </a:prstGeom>
+          <a:noFill/>
+          <a:ln>
+            <a:solidFill>
+              <a:srgbClr val="A5355C"/>
+            </a:solidFill>
+          </a:ln>
+        </p:spPr>
+        <p:style>
+          <a:lnRef idx="2">
+            <a:schemeClr val="accent1">
+              <a:shade val="15000"/>
+            </a:schemeClr>
+          </a:lnRef>
+          <a:fillRef idx="1">
+            <a:schemeClr val="accent1"/>
+          </a:fillRef>
+          <a:effectRef idx="0">
+            <a:schemeClr val="accent1"/>
+          </a:effectRef>
+          <a:fontRef idx="minor">
+            <a:schemeClr val="lt1"/>
+          </a:fontRef>
+        </p:style>
+        <p:txBody>
+          <a:bodyPr rtlCol="0" anchor="ctr"/>
+          <a:lstStyle/>
+          <a:p>
+            <a:pPr algn="ctr"/>
+            <a:endParaRPr lang="de-DE" dirty="0">
+              <a:solidFill>
+                <a:srgbClr val="A5355C"/>
+              </a:solidFill>
+              <a:latin typeface="Lucida Console" panose="020B0609040504020204" pitchFamily="49" charset="0"/>
+            </a:endParaRPr>
+          </a:p>
+        </p:txBody>
+      </p:sp>
+      <p:sp>
+        <p:nvSpPr>
+          <p:cNvPr id="11" name="Rectangle 10">
+            <a:extLst>
+              <a:ext uri="{FF2B5EF4-FFF2-40B4-BE49-F238E27FC236}">
+                <a16:creationId xmlns:a16="http://schemas.microsoft.com/office/drawing/2014/main" id="{C0399A9B-3BA3-02B9-5FAA-AAAF4B05E9A3}"/>
+              </a:ext>
+            </a:extLst>
+          </p:cNvPr>
+          <p:cNvSpPr/>
+          <p:nvPr/>
+        </p:nvSpPr>
+        <p:spPr>
+          <a:xfrm>
+            <a:off x="6816008" y="3429000"/>
+            <a:ext cx="943747" cy="439056"/>
+          </a:xfrm>
+          <a:prstGeom prst="rect">
+            <a:avLst/>
+          </a:prstGeom>
+          <a:noFill/>
+          <a:ln>
+            <a:solidFill>
+              <a:srgbClr val="A5355C"/>
+            </a:solidFill>
+          </a:ln>
+        </p:spPr>
+        <p:style>
+          <a:lnRef idx="2">
+            <a:schemeClr val="accent1">
+              <a:shade val="15000"/>
+            </a:schemeClr>
+          </a:lnRef>
+          <a:fillRef idx="1">
+            <a:schemeClr val="accent1"/>
+          </a:fillRef>
+          <a:effectRef idx="0">
+            <a:schemeClr val="accent1"/>
+          </a:effectRef>
+          <a:fontRef idx="minor">
+            <a:schemeClr val="lt1"/>
+          </a:fontRef>
+        </p:style>
+        <p:txBody>
+          <a:bodyPr rtlCol="0" anchor="ctr"/>
+          <a:lstStyle/>
+          <a:p>
+            <a:pPr algn="ctr"/>
+            <a:endParaRPr lang="de-DE" dirty="0">
+              <a:solidFill>
+                <a:srgbClr val="A5355C"/>
+              </a:solidFill>
+              <a:latin typeface="Lucida Console" panose="020B0609040504020204" pitchFamily="49" charset="0"/>
+            </a:endParaRPr>
+          </a:p>
+        </p:txBody>
+      </p:sp>
+    </p:spTree>
+    <p:extLst>
+      <p:ext uri="{BB962C8B-B14F-4D97-AF65-F5344CB8AC3E}">
+        <p14:creationId xmlns:p14="http://schemas.microsoft.com/office/powerpoint/2010/main" val="3910994640"/>
       </p:ext>
     </p:extLst>
   </p:cSld>

</xml_diff>